<commit_message>
Review 2 deck: new Results screenshots
Results slide now shows the current sign-in, home, archive and dialect
shelf screens; the recording page and the result bullets move to a
Results (continued) slide, updated to 140 dialects and 110+ tests.

Co-Authored-By: Claude Opus 5.5 <noreply@anthropic.com>
Claude-Session: https://claude.ai/code/session_01PMpArZdsd629bbEiEsWqT8
</commit_message>
<xml_diff>
--- a/docs/SwaraVeda_Review2_2.pptx
+++ b/docs/SwaraVeda_Review2_2.pptx
@@ -5,7 +5,7 @@
     <p:sldMasterId id="2147483676" r:id="rId1"/>
   </p:sldMasterIdLst>
   <p:notesMasterIdLst>
-    <p:notesMasterId r:id="rId14"/>
+    <p:notesMasterId r:id="rId15"/>
   </p:notesMasterIdLst>
   <p:sldIdLst>
     <p:sldId id="279" r:id="rId2"/>
@@ -15,22 +15,23 @@
     <p:sldId id="289" r:id="rId6"/>
     <p:sldId id="288" r:id="rId7"/>
     <p:sldId id="287" r:id="rId8"/>
-    <p:sldId id="292" r:id="rId170"/>
-    <p:sldId id="286" r:id="rId9"/>
-    <p:sldId id="285" r:id="rId10"/>
-    <p:sldId id="284" r:id="rId11"/>
-    <p:sldId id="283" r:id="rId12"/>
-    <p:sldId id="282" r:id="rId13"/>
+    <p:sldId id="292" r:id="rId9"/>
+    <p:sldId id="286" r:id="rId10"/>
+    <p:sldId id="293" r:id="rId170"/>
+    <p:sldId id="285" r:id="rId11"/>
+    <p:sldId id="284" r:id="rId12"/>
+    <p:sldId id="283" r:id="rId13"/>
+    <p:sldId id="282" r:id="rId14"/>
   </p:sldIdLst>
   <p:sldSz cx="9144000" cy="6858000" type="screen4x3"/>
   <p:notesSz cx="7010400" cy="9296400"/>
   <p:embeddedFontLst>
     <p:embeddedFont>
       <p:font typeface="Verdana" panose="020B0604030504040204" pitchFamily="34" charset="0"/>
-      <p:regular r:id="rId15"/>
-      <p:bold r:id="rId16"/>
-      <p:italic r:id="rId17"/>
-      <p:boldItalic r:id="rId18"/>
+      <p:regular r:id="rId16"/>
+      <p:bold r:id="rId17"/>
+      <p:italic r:id="rId18"/>
+      <p:boldItalic r:id="rId19"/>
     </p:embeddedFont>
   </p:embeddedFontLst>
   <p:defaultTextStyle>
@@ -267,7 +268,7 @@
       <p15:sldGuideLst xmlns:p15="http://schemas.microsoft.com/office/powerpoint/2012/main"/>
     </p:ext>
     <p:ext uri="GoogleSlidesCustomDataVersion2">
-      <go:slidesCustomData xmlns:go="http://customooxmlschemas.google.com/" xmlns:ahyp="http://schemas.microsoft.com/office/drawing/2018/hyperlinkcolor" xmlns:p15="http://schemas.microsoft.com/office/powerpoint/2012/main" xmlns:p14="http://schemas.microsoft.com/office/powerpoint/2010/main" xmlns:com="http://schemas.openxmlformats.org/drawingml/2006/compatibility" xmlns:pvml="urn:schemas-microsoft-com:office:powerpoint" xmlns:v="urn:schemas-microsoft-com:vml" xmlns:o="urn:schemas-microsoft-com:office:office" xmlns:dgm="http://schemas.openxmlformats.org/drawingml/2006/diagram" xmlns:c="http://schemas.openxmlformats.org/drawingml/2006/chart" xmlns:mv="urn:schemas-microsoft-com:mac:vml" xmlns:mc="http://schemas.openxmlformats.org/markup-compatibility/2006" xmlns="" r:id="rId163" roundtripDataSignature="AMtx7mgtpVR0efpXsYw/YFNiXHcO2TZrfw=="/>
+      <go:slidesCustomData xmlns="" xmlns:mc="http://schemas.openxmlformats.org/markup-compatibility/2006" xmlns:mv="urn:schemas-microsoft-com:mac:vml" xmlns:c="http://schemas.openxmlformats.org/drawingml/2006/chart" xmlns:dgm="http://schemas.openxmlformats.org/drawingml/2006/diagram" xmlns:o="urn:schemas-microsoft-com:office:office" xmlns:v="urn:schemas-microsoft-com:vml" xmlns:pvml="urn:schemas-microsoft-com:office:powerpoint" xmlns:com="http://schemas.openxmlformats.org/drawingml/2006/compatibility" xmlns:p14="http://schemas.microsoft.com/office/powerpoint/2010/main" xmlns:p15="http://schemas.microsoft.com/office/powerpoint/2012/main" xmlns:ahyp="http://schemas.microsoft.com/office/drawing/2018/hyperlinkcolor" xmlns:go="http://customooxmlschemas.google.com/" r:id="rId163" roundtripDataSignature="AMtx7mgtpVR0efpXsYw/YFNiXHcO2TZrfw=="/>
     </p:ext>
   </p:extLst>
 </p:presentation>
@@ -5069,262 +5070,36 @@
           <a:chExt cx="0" cy="0"/>
         </a:xfrm>
       </p:grpSpPr>
-      <p:sp>
-        <p:nvSpPr>
-          <p:cNvPr id="3" name="Google Shape;68;g78e6671419f8a2a0_22">
+      <p:pic>
+        <p:nvPicPr>
+          <p:cNvPr id="4" name="Picture 3">
             <a:extLst>
               <a:ext uri="{FF2B5EF4-FFF2-40B4-BE49-F238E27FC236}">
-                <a16:creationId xmlns:a16="http://schemas.microsoft.com/office/drawing/2014/main" id="{BA677A83-D006-E1F4-CCF8-948027C21AB2}"/>
+                <a16:creationId xmlns:a16="http://schemas.microsoft.com/office/drawing/2014/main" id="{2CBC3EA0-6A61-A69C-F4DE-DAFDF30506BA}"/>
               </a:ext>
             </a:extLst>
           </p:cNvPr>
-          <p:cNvSpPr txBox="1"/>
+          <p:cNvPicPr>
+            <a:picLocks noChangeAspect="1"/>
+          </p:cNvPicPr>
           <p:nvPr/>
-        </p:nvSpPr>
+        </p:nvPicPr>
+        <p:blipFill>
+          <a:blip r:embed="rId2"/>
+          <a:stretch>
+            <a:fillRect/>
+          </a:stretch>
+        </p:blipFill>
         <p:spPr>
           <a:xfrm>
-            <a:off x="628650" y="1131097"/>
-            <a:ext cx="7886700" cy="994275"/>
+            <a:off x="0" y="1316736"/>
+            <a:ext cx="9143999" cy="5541264"/>
           </a:xfrm>
           <a:prstGeom prst="rect">
             <a:avLst/>
           </a:prstGeom>
-          <a:noFill/>
-          <a:ln>
-            <a:noFill/>
-          </a:ln>
         </p:spPr>
-        <p:txBody>
-          <a:bodyPr spcFirstLastPara="1" wrap="square" lIns="68569" tIns="34275" rIns="68569" bIns="34275" anchor="ctr" anchorCtr="0">
-            <a:normAutofit/>
-          </a:bodyPr>
-          <a:lstStyle/>
-          <a:p>
-            <a:pPr algn="ctr" defTabSz="685800">
-              <a:lnSpc>
-                <a:spcPct val="90000"/>
-              </a:lnSpc>
-            </a:pPr>
-            <a:r>
-              <a:rPr lang="en-GB" sz="2400" dirty="0">
-                <a:latin typeface="Times New Roman" panose="02020603050405020304" pitchFamily="18" charset="0"/>
-                <a:cs typeface="Times New Roman" panose="02020603050405020304" pitchFamily="18" charset="0"/>
-              </a:rPr>
-              <a:t>Work to be completed</a:t>
-            </a:r>
-            <a:endParaRPr sz="2400" dirty="0">
-              <a:latin typeface="Times New Roman" panose="02020603050405020304" pitchFamily="18" charset="0"/>
-              <a:cs typeface="Times New Roman" panose="02020603050405020304" pitchFamily="18" charset="0"/>
-            </a:endParaRPr>
-          </a:p>
-        </p:txBody>
-      </p:sp>
-      <p:sp>
-        <p:nvSpPr>
-          <p:cNvPr id="5" name="Google Shape;69;g78e6671419f8a2a0_22">
-            <a:extLst>
-              <a:ext uri="{FF2B5EF4-FFF2-40B4-BE49-F238E27FC236}">
-                <a16:creationId xmlns:a16="http://schemas.microsoft.com/office/drawing/2014/main" id="{13186C97-59A2-67F5-3892-203B43C861C9}"/>
-              </a:ext>
-            </a:extLst>
-          </p:cNvPr>
-          <p:cNvSpPr txBox="1"/>
-          <p:nvPr/>
-        </p:nvSpPr>
-        <p:spPr>
-          <a:xfrm>
-            <a:off x="822960" y="2011680"/>
-            <a:ext cx="7589520" cy="4206240"/>
-          </a:xfrm>
-          <a:prstGeom prst="rect">
-            <a:avLst/>
-          </a:prstGeom>
-          <a:noFill/>
-          <a:ln>
-            <a:noFill/>
-          </a:ln>
-        </p:spPr>
-        <p:txBody>
-          <a:bodyPr spcFirstLastPara="1" wrap="square" lIns="68569" tIns="34275" rIns="68569" bIns="34275" anchor="t" anchorCtr="0">
-            <a:noAutofit/>
-          </a:bodyPr>
-          <a:lstStyle/>
-          <a:p>
-            <a:pPr marL="457200" indent="-342900">
-              <a:lnSpc>
-                <a:spcPct val="90000"/>
-              </a:lnSpc>
-              <a:spcBef>
-                <a:spcPts val="1100"/>
-              </a:spcBef>
-              <a:buSzPts val="1800"/>
-              <a:buFont typeface="Arial"/>
-              <a:buChar char="•"/>
-            </a:pPr>
-            <a:r>
-              <a:rPr lang="en-US" sz="1600" b="1" dirty="0">
-                <a:solidFill>
-                  <a:srgbClr val="595959"/>
-                </a:solidFill>
-              </a:rPr>
-              <a:t>Field data: </a:t>
-            </a:r>
-            <a:r>
-              <a:rPr lang="en-US" sz="1600" dirty="0">
-                <a:solidFill>
-                  <a:srgbClr val="595959"/>
-                </a:solidFill>
-              </a:rPr>
-              <a:t>record with Tulu and Kodava speakers; correct and verify the transcripts</a:t>
-            </a:r>
-          </a:p>
-          <a:p>
-            <a:pPr marL="457200" indent="-342900">
-              <a:lnSpc>
-                <a:spcPct val="90000"/>
-              </a:lnSpc>
-              <a:spcBef>
-                <a:spcPts val="1100"/>
-              </a:spcBef>
-              <a:buSzPts val="1800"/>
-              <a:buFont typeface="Arial"/>
-              <a:buChar char="•"/>
-            </a:pPr>
-            <a:r>
-              <a:rPr lang="en-US" sz="1600" b="1" dirty="0">
-                <a:solidFill>
-                  <a:srgbClr val="595959"/>
-                </a:solidFill>
-              </a:rPr>
-              <a:t>Storage setup: </a:t>
-            </a:r>
-            <a:r>
-              <a:rPr lang="en-US" sz="1600" dirty="0">
-                <a:solidFill>
-                  <a:srgbClr val="595959"/>
-                </a:solidFill>
-              </a:rPr>
-              <a:t>finish the cloud storage configuration so uploads work on the live server</a:t>
-            </a:r>
-          </a:p>
-          <a:p>
-            <a:pPr marL="457200" indent="-342900">
-              <a:lnSpc>
-                <a:spcPct val="90000"/>
-              </a:lnSpc>
-              <a:spcBef>
-                <a:spcPts val="1100"/>
-              </a:spcBef>
-              <a:buSzPts val="1800"/>
-              <a:buFont typeface="Arial"/>
-              <a:buChar char="•"/>
-            </a:pPr>
-            <a:r>
-              <a:rPr lang="en-US" sz="1600" b="1" dirty="0">
-                <a:solidFill>
-                  <a:srgbClr val="595959"/>
-                </a:solidFill>
-              </a:rPr>
-              <a:t>Dataset dashboard: </a:t>
-            </a:r>
-            <a:r>
-              <a:rPr lang="en-US" sz="1600" dirty="0">
-                <a:solidFill>
-                  <a:srgbClr val="595959"/>
-                </a:solidFill>
-              </a:rPr>
-              <a:t>show how many verified hours Vani has for each dialect</a:t>
-            </a:r>
-          </a:p>
-          <a:p>
-            <a:pPr marL="457200" indent="-342900">
-              <a:lnSpc>
-                <a:spcPct val="90000"/>
-              </a:lnSpc>
-              <a:spcBef>
-                <a:spcPts val="1100"/>
-              </a:spcBef>
-              <a:buSzPts val="1800"/>
-              <a:buFont typeface="Arial"/>
-              <a:buChar char="•"/>
-            </a:pPr>
-            <a:r>
-              <a:rPr lang="en-US" sz="1600" b="1" dirty="0">
-                <a:solidFill>
-                  <a:srgbClr val="595959"/>
-                </a:solidFill>
-              </a:rPr>
-              <a:t>Speakers: </a:t>
-            </a:r>
-            <a:r>
-              <a:rPr lang="en-US" sz="1600" dirty="0">
-                <a:solidFill>
-                  <a:srgbClr val="595959"/>
-                </a:solidFill>
-              </a:rPr>
-              <a:t>tell speakers apart in a recording (diarization)</a:t>
-            </a:r>
-          </a:p>
-          <a:p>
-            <a:pPr marL="457200" indent="-342900">
-              <a:lnSpc>
-                <a:spcPct val="90000"/>
-              </a:lnSpc>
-              <a:spcBef>
-                <a:spcPts val="1100"/>
-              </a:spcBef>
-              <a:buSzPts val="1800"/>
-              <a:buFont typeface="Arial"/>
-              <a:buChar char="•"/>
-            </a:pPr>
-            <a:r>
-              <a:rPr lang="en-US" sz="1600" b="1" dirty="0">
-                <a:solidFill>
-                  <a:srgbClr val="595959"/>
-                </a:solidFill>
-              </a:rPr>
-              <a:t>Accessibility: </a:t>
-            </a:r>
-            <a:r>
-              <a:rPr lang="en-US" sz="1600" dirty="0">
-                <a:solidFill>
-                  <a:srgbClr val="595959"/>
-                </a:solidFill>
-              </a:rPr>
-              <a:t>interface in Kannada, Hindi and other Indian languages</a:t>
-            </a:r>
-          </a:p>
-          <a:p>
-            <a:pPr marL="457200" indent="-342900">
-              <a:lnSpc>
-                <a:spcPct val="90000"/>
-              </a:lnSpc>
-              <a:spcBef>
-                <a:spcPts val="1100"/>
-              </a:spcBef>
-              <a:buSzPts val="1800"/>
-              <a:buFont typeface="Arial"/>
-              <a:buChar char="•"/>
-            </a:pPr>
-            <a:r>
-              <a:rPr lang="en-US" sz="1600" b="1" dirty="0">
-                <a:solidFill>
-                  <a:srgbClr val="595959"/>
-                </a:solidFill>
-              </a:rPr>
-              <a:t>Train Vani: </a:t>
-            </a:r>
-            <a:r>
-              <a:rPr lang="en-US" sz="1600" dirty="0">
-                <a:solidFill>
-                  <a:srgbClr val="595959"/>
-                </a:solidFill>
-              </a:rPr>
-              <a:t>fine-tune Whisper on the exported dataset and measure word error rate</a:t>
-            </a:r>
-          </a:p>
-        </p:txBody>
-      </p:sp>
+      </p:pic>
     </p:spTree>
   </p:cSld>
   <p:clrMapOvr>
@@ -5391,6 +5166,287 @@
                 <a:latin typeface="Times New Roman" panose="02020603050405020304" pitchFamily="18" charset="0"/>
                 <a:cs typeface="Times New Roman" panose="02020603050405020304" pitchFamily="18" charset="0"/>
               </a:rPr>
+              <a:t>Work to be completed</a:t>
+            </a:r>
+            <a:endParaRPr sz="2400" dirty="0">
+              <a:latin typeface="Times New Roman" panose="02020603050405020304" pitchFamily="18" charset="0"/>
+              <a:cs typeface="Times New Roman" panose="02020603050405020304" pitchFamily="18" charset="0"/>
+            </a:endParaRPr>
+          </a:p>
+        </p:txBody>
+      </p:sp>
+      <p:sp>
+        <p:nvSpPr>
+          <p:cNvPr id="5" name="Google Shape;69;g78e6671419f8a2a0_22">
+            <a:extLst>
+              <a:ext uri="{FF2B5EF4-FFF2-40B4-BE49-F238E27FC236}">
+                <a16:creationId xmlns:a16="http://schemas.microsoft.com/office/drawing/2014/main" id="{13186C97-59A2-67F5-3892-203B43C861C9}"/>
+              </a:ext>
+            </a:extLst>
+          </p:cNvPr>
+          <p:cNvSpPr txBox="1"/>
+          <p:nvPr/>
+        </p:nvSpPr>
+        <p:spPr>
+          <a:xfrm>
+            <a:off x="822960" y="2011680"/>
+            <a:ext cx="7589520" cy="4206240"/>
+          </a:xfrm>
+          <a:prstGeom prst="rect">
+            <a:avLst/>
+          </a:prstGeom>
+          <a:noFill/>
+          <a:ln>
+            <a:noFill/>
+          </a:ln>
+        </p:spPr>
+        <p:txBody>
+          <a:bodyPr spcFirstLastPara="1" wrap="square" lIns="68569" tIns="34275" rIns="68569" bIns="34275" anchor="t" anchorCtr="0">
+            <a:noAutofit/>
+          </a:bodyPr>
+          <a:lstStyle/>
+          <a:p>
+            <a:pPr marL="457200" indent="-342900">
+              <a:lnSpc>
+                <a:spcPct val="90000"/>
+              </a:lnSpc>
+              <a:spcBef>
+                <a:spcPts val="1100"/>
+              </a:spcBef>
+              <a:buSzPts val="1800"/>
+              <a:buFont typeface="Arial"/>
+              <a:buChar char="•"/>
+            </a:pPr>
+            <a:r>
+              <a:rPr lang="en-US" sz="1600" b="1" dirty="0">
+                <a:solidFill>
+                  <a:srgbClr val="595959"/>
+                </a:solidFill>
+              </a:rPr>
+              <a:t>Field data: </a:t>
+            </a:r>
+            <a:r>
+              <a:rPr lang="en-US" sz="1600" dirty="0">
+                <a:solidFill>
+                  <a:srgbClr val="595959"/>
+                </a:solidFill>
+              </a:rPr>
+              <a:t>record with Tulu and Kodava speakers; correct and verify the transcripts</a:t>
+            </a:r>
+          </a:p>
+          <a:p>
+            <a:pPr marL="457200" indent="-342900">
+              <a:lnSpc>
+                <a:spcPct val="90000"/>
+              </a:lnSpc>
+              <a:spcBef>
+                <a:spcPts val="1100"/>
+              </a:spcBef>
+              <a:buSzPts val="1800"/>
+              <a:buFont typeface="Arial"/>
+              <a:buChar char="•"/>
+            </a:pPr>
+            <a:r>
+              <a:rPr lang="en-US" sz="1600" b="1" dirty="0">
+                <a:solidFill>
+                  <a:srgbClr val="595959"/>
+                </a:solidFill>
+              </a:rPr>
+              <a:t>Storage setup: </a:t>
+            </a:r>
+            <a:r>
+              <a:rPr lang="en-US" sz="1600" dirty="0">
+                <a:solidFill>
+                  <a:srgbClr val="595959"/>
+                </a:solidFill>
+              </a:rPr>
+              <a:t>finish the cloud storage configuration so uploads work on the live server</a:t>
+            </a:r>
+          </a:p>
+          <a:p>
+            <a:pPr marL="457200" indent="-342900">
+              <a:lnSpc>
+                <a:spcPct val="90000"/>
+              </a:lnSpc>
+              <a:spcBef>
+                <a:spcPts val="1100"/>
+              </a:spcBef>
+              <a:buSzPts val="1800"/>
+              <a:buFont typeface="Arial"/>
+              <a:buChar char="•"/>
+            </a:pPr>
+            <a:r>
+              <a:rPr lang="en-US" sz="1600" b="1" dirty="0">
+                <a:solidFill>
+                  <a:srgbClr val="595959"/>
+                </a:solidFill>
+              </a:rPr>
+              <a:t>Dataset dashboard: </a:t>
+            </a:r>
+            <a:r>
+              <a:rPr lang="en-US" sz="1600" dirty="0">
+                <a:solidFill>
+                  <a:srgbClr val="595959"/>
+                </a:solidFill>
+              </a:rPr>
+              <a:t>show how many verified hours Vani has for each dialect</a:t>
+            </a:r>
+          </a:p>
+          <a:p>
+            <a:pPr marL="457200" indent="-342900">
+              <a:lnSpc>
+                <a:spcPct val="90000"/>
+              </a:lnSpc>
+              <a:spcBef>
+                <a:spcPts val="1100"/>
+              </a:spcBef>
+              <a:buSzPts val="1800"/>
+              <a:buFont typeface="Arial"/>
+              <a:buChar char="•"/>
+            </a:pPr>
+            <a:r>
+              <a:rPr lang="en-US" sz="1600" b="1" dirty="0">
+                <a:solidFill>
+                  <a:srgbClr val="595959"/>
+                </a:solidFill>
+              </a:rPr>
+              <a:t>Speakers: </a:t>
+            </a:r>
+            <a:r>
+              <a:rPr lang="en-US" sz="1600" dirty="0">
+                <a:solidFill>
+                  <a:srgbClr val="595959"/>
+                </a:solidFill>
+              </a:rPr>
+              <a:t>tell speakers apart in a recording (diarization)</a:t>
+            </a:r>
+          </a:p>
+          <a:p>
+            <a:pPr marL="457200" indent="-342900">
+              <a:lnSpc>
+                <a:spcPct val="90000"/>
+              </a:lnSpc>
+              <a:spcBef>
+                <a:spcPts val="1100"/>
+              </a:spcBef>
+              <a:buSzPts val="1800"/>
+              <a:buFont typeface="Arial"/>
+              <a:buChar char="•"/>
+            </a:pPr>
+            <a:r>
+              <a:rPr lang="en-US" sz="1600" b="1" dirty="0">
+                <a:solidFill>
+                  <a:srgbClr val="595959"/>
+                </a:solidFill>
+              </a:rPr>
+              <a:t>Accessibility: </a:t>
+            </a:r>
+            <a:r>
+              <a:rPr lang="en-US" sz="1600" dirty="0">
+                <a:solidFill>
+                  <a:srgbClr val="595959"/>
+                </a:solidFill>
+              </a:rPr>
+              <a:t>interface in Kannada, Hindi and other Indian languages</a:t>
+            </a:r>
+          </a:p>
+          <a:p>
+            <a:pPr marL="457200" indent="-342900">
+              <a:lnSpc>
+                <a:spcPct val="90000"/>
+              </a:lnSpc>
+              <a:spcBef>
+                <a:spcPts val="1100"/>
+              </a:spcBef>
+              <a:buSzPts val="1800"/>
+              <a:buFont typeface="Arial"/>
+              <a:buChar char="•"/>
+            </a:pPr>
+            <a:r>
+              <a:rPr lang="en-US" sz="1600" b="1" dirty="0">
+                <a:solidFill>
+                  <a:srgbClr val="595959"/>
+                </a:solidFill>
+              </a:rPr>
+              <a:t>Train Vani: </a:t>
+            </a:r>
+            <a:r>
+              <a:rPr lang="en-US" sz="1600" dirty="0">
+                <a:solidFill>
+                  <a:srgbClr val="595959"/>
+                </a:solidFill>
+              </a:rPr>
+              <a:t>fine-tune Whisper on the exported dataset and measure word error rate</a:t>
+            </a:r>
+          </a:p>
+        </p:txBody>
+      </p:sp>
+    </p:spTree>
+  </p:cSld>
+  <p:clrMapOvr>
+    <a:masterClrMapping/>
+  </p:clrMapOvr>
+</p:sld>
+</file>
+
+<file path=ppt/slides/slide12.xml><?xml version="1.0" encoding="utf-8"?>
+<p:sld xmlns:a="http://schemas.openxmlformats.org/drawingml/2006/main" xmlns:r="http://schemas.openxmlformats.org/officeDocument/2006/relationships" xmlns:p="http://schemas.openxmlformats.org/presentationml/2006/main">
+  <p:cSld>
+    <p:spTree>
+      <p:nvGrpSpPr>
+        <p:cNvPr id="1" name="Shape 57"/>
+        <p:cNvGrpSpPr/>
+        <p:nvPr/>
+      </p:nvGrpSpPr>
+      <p:grpSpPr>
+        <a:xfrm>
+          <a:off x="0" y="0"/>
+          <a:ext cx="0" cy="0"/>
+          <a:chOff x="0" y="0"/>
+          <a:chExt cx="0" cy="0"/>
+        </a:xfrm>
+      </p:grpSpPr>
+      <p:sp>
+        <p:nvSpPr>
+          <p:cNvPr id="3" name="Google Shape;68;g78e6671419f8a2a0_22">
+            <a:extLst>
+              <a:ext uri="{FF2B5EF4-FFF2-40B4-BE49-F238E27FC236}">
+                <a16:creationId xmlns:a16="http://schemas.microsoft.com/office/drawing/2014/main" id="{BA677A83-D006-E1F4-CCF8-948027C21AB2}"/>
+              </a:ext>
+            </a:extLst>
+          </p:cNvPr>
+          <p:cNvSpPr txBox="1"/>
+          <p:nvPr/>
+        </p:nvSpPr>
+        <p:spPr>
+          <a:xfrm>
+            <a:off x="628650" y="1131097"/>
+            <a:ext cx="7886700" cy="994275"/>
+          </a:xfrm>
+          <a:prstGeom prst="rect">
+            <a:avLst/>
+          </a:prstGeom>
+          <a:noFill/>
+          <a:ln>
+            <a:noFill/>
+          </a:ln>
+        </p:spPr>
+        <p:txBody>
+          <a:bodyPr spcFirstLastPara="1" wrap="square" lIns="68569" tIns="34275" rIns="68569" bIns="34275" anchor="ctr" anchorCtr="0">
+            <a:normAutofit/>
+          </a:bodyPr>
+          <a:lstStyle/>
+          <a:p>
+            <a:pPr algn="ctr" defTabSz="685800">
+              <a:lnSpc>
+                <a:spcPct val="90000"/>
+              </a:lnSpc>
+            </a:pPr>
+            <a:r>
+              <a:rPr lang="en-GB" sz="2400" dirty="0">
+                <a:latin typeface="Times New Roman" panose="02020603050405020304" pitchFamily="18" charset="0"/>
+                <a:cs typeface="Times New Roman" panose="02020603050405020304" pitchFamily="18" charset="0"/>
+              </a:rPr>
               <a:t>References</a:t>
             </a:r>
             <a:endParaRPr sz="2400" dirty="0">
@@ -5680,7 +5736,7 @@
 </p:sld>
 </file>
 
-<file path=ppt/slides/slide12.xml><?xml version="1.0" encoding="utf-8"?>
+<file path=ppt/slides/slide13.xml><?xml version="1.0" encoding="utf-8"?>
 <p:sld xmlns:a="http://schemas.openxmlformats.org/drawingml/2006/main" xmlns:r="http://schemas.openxmlformats.org/officeDocument/2006/relationships" xmlns:p="http://schemas.openxmlformats.org/presentationml/2006/main">
   <p:cSld>
     <p:spTree>
@@ -5769,7 +5825,7 @@
 </p:sld>
 </file>
 
-<file path=ppt/slides/slide13.xml><?xml version="1.0" encoding="utf-8"?>
+<file path=ppt/slides/slide14.xml><?xml version="1.0" encoding="utf-8"?>
 <p:sld xmlns:a="http://schemas.openxmlformats.org/drawingml/2006/main" xmlns:r="http://schemas.openxmlformats.org/officeDocument/2006/relationships" xmlns:p="http://schemas.openxmlformats.org/presentationml/2006/main">
   <p:cSld>
     <p:spTree>
@@ -5827,7 +5883,7 @@
                 <a:latin typeface="Times New Roman" panose="02020603050405020304" pitchFamily="18" charset="0"/>
                 <a:cs typeface="Times New Roman" panose="02020603050405020304" pitchFamily="18" charset="0"/>
               </a:rPr>
-              <a:t>Implementation Details (Algorithm)</a:t>
+              <a:t>Results (continued)</a:t>
             </a:r>
             <a:endParaRPr sz="2400" dirty="0">
               <a:latin typeface="Times New Roman" panose="02020603050405020304" pitchFamily="18" charset="0"/>
@@ -5836,188 +5892,45 @@
           </a:p>
         </p:txBody>
       </p:sp>
+      <p:pic>
+        <p:nvPicPr>
+          <p:cNvPr id="6" name="Picture 5" descr="recording.png"/>
+          <p:cNvPicPr>
+            <a:picLocks noChangeAspect="1"/>
+          </p:cNvPicPr>
+          <p:nvPr/>
+        </p:nvPicPr>
+        <p:blipFill>
+          <a:blip r:embed="rId3"/>
+          <a:stretch>
+            <a:fillRect/>
+          </a:stretch>
+        </p:blipFill>
+        <p:spPr>
+          <a:xfrm>
+            <a:off x="2834640" y="1920240"/>
+            <a:ext cx="3474720" cy="2171700"/>
+          </a:xfrm>
+          <a:prstGeom prst="rect">
+            <a:avLst/>
+          </a:prstGeom>
+          <a:ln w="9525">
+            <a:solidFill>
+              <a:srgbClr val="8C8C8C"/>
+            </a:solidFill>
+          </a:ln>
+        </p:spPr>
+      </p:pic>
       <p:sp>
         <p:nvSpPr>
-          <p:cNvPr id="5" name="Google Shape;69;g78e6671419f8a2a0_22">
-            <a:extLst>
-              <a:ext uri="{FF2B5EF4-FFF2-40B4-BE49-F238E27FC236}">
-                <a16:creationId xmlns:a16="http://schemas.microsoft.com/office/drawing/2014/main" id="{13186C97-59A2-67F5-3892-203B43C861C9}"/>
-              </a:ext>
-            </a:extLst>
-          </p:cNvPr>
+          <p:cNvPr id="7" name="TextBox 6"/>
           <p:cNvSpPr txBox="1"/>
           <p:nvPr/>
         </p:nvSpPr>
         <p:spPr>
           <a:xfrm>
-            <a:off x="822960" y="2286000"/>
-            <a:ext cx="7589520" cy="2834640"/>
-          </a:xfrm>
-          <a:prstGeom prst="rect">
-            <a:avLst/>
-          </a:prstGeom>
-          <a:noFill/>
-          <a:ln>
-            <a:noFill/>
-          </a:ln>
-        </p:spPr>
-        <p:txBody>
-          <a:bodyPr spcFirstLastPara="1" wrap="square" lIns="68569" tIns="34275" rIns="68569" bIns="34275" anchor="t" anchorCtr="0">
-            <a:noAutofit/>
-          </a:bodyPr>
-          <a:lstStyle/>
-          <a:p>
-            <a:pPr marL="457200" indent="-342900">
-              <a:lnSpc>
-                <a:spcPct val="90000"/>
-              </a:lnSpc>
-              <a:spcBef>
-                <a:spcPts val="700"/>
-              </a:spcBef>
-              <a:buFont typeface="+mj-lt"/>
-              <a:buAutoNum type="arabicPeriod"/>
-            </a:pPr>
-            <a:r>
-              <a:rPr lang="en-US" sz="1400" dirty="0">
-                <a:solidFill>
-                  <a:srgbClr val="595959"/>
-                </a:solidFill>
-              </a:rPr>
-              <a:t>If a job for R is queued or running, return it; otherwise create job J</a:t>
-            </a:r>
-          </a:p>
-          <a:p>
-            <a:pPr marL="457200" indent="-342900">
-              <a:lnSpc>
-                <a:spcPct val="90000"/>
-              </a:lnSpc>
-              <a:spcBef>
-                <a:spcPts val="700"/>
-              </a:spcBef>
-              <a:buFont typeface="+mj-lt"/>
-              <a:buAutoNum type="arabicPeriod"/>
-            </a:pPr>
-            <a:r>
-              <a:rPr lang="en-US" sz="1400" dirty="0">
-                <a:solidFill>
-                  <a:srgbClr val="595959"/>
-                </a:solidFill>
-              </a:rPr>
-              <a:t>Download R’s audio (up to 200 MB)</a:t>
-            </a:r>
-          </a:p>
-          <a:p>
-            <a:pPr marL="457200" indent="-342900">
-              <a:lnSpc>
-                <a:spcPct val="90000"/>
-              </a:lnSpc>
-              <a:spcBef>
-                <a:spcPts val="700"/>
-              </a:spcBef>
-              <a:buFont typeface="+mj-lt"/>
-              <a:buAutoNum type="arabicPeriod"/>
-            </a:pPr>
-            <a:r>
-              <a:rPr lang="en-US" sz="1400" dirty="0">
-                <a:solidFill>
-                  <a:srgbClr val="595959"/>
-                </a:solidFill>
-              </a:rPr>
-              <a:t>a ← ffmpeg(audio): mono, 16 kHz, high-pass 80 Hz, loudness −18 LUFS, Opus 32 kbps</a:t>
-            </a:r>
-          </a:p>
-          <a:p>
-            <a:pPr marL="457200" indent="-342900">
-              <a:lnSpc>
-                <a:spcPct val="90000"/>
-              </a:lnSpc>
-              <a:spcBef>
-                <a:spcPts val="700"/>
-              </a:spcBef>
-              <a:buFont typeface="+mj-lt"/>
-              <a:buAutoNum type="arabicPeriod"/>
-            </a:pPr>
-            <a:r>
-              <a:rPr lang="en-US" sz="1400" dirty="0">
-                <a:solidFill>
-                  <a:srgbClr val="595959"/>
-                </a:solidFill>
-              </a:rPr>
-              <a:t>S ← Whisper-large-v3(a, language = D.asr_language) → timestamped segments</a:t>
-            </a:r>
-          </a:p>
-          <a:p>
-            <a:pPr marL="457200" indent="-342900">
-              <a:lnSpc>
-                <a:spcPct val="90000"/>
-              </a:lnSpc>
-              <a:spcBef>
-                <a:spcPts val="700"/>
-              </a:spcBef>
-              <a:buFont typeface="+mj-lt"/>
-              <a:buAutoNum type="arabicPeriod"/>
-            </a:pPr>
-            <a:r>
-              <a:rPr lang="en-US" sz="1400" dirty="0">
-                <a:solidFill>
-                  <a:srgbClr val="595959"/>
-                </a:solidFill>
-              </a:rPr>
-              <a:t>Replace R’s segments with S;  R.status ← transcribed</a:t>
-            </a:r>
-          </a:p>
-          <a:p>
-            <a:pPr marL="457200" indent="-342900">
-              <a:lnSpc>
-                <a:spcPct val="90000"/>
-              </a:lnSpc>
-              <a:spcBef>
-                <a:spcPts val="700"/>
-              </a:spcBef>
-              <a:buFont typeface="+mj-lt"/>
-              <a:buAutoNum type="arabicPeriod"/>
-            </a:pPr>
-            <a:r>
-              <a:rPr lang="en-US" sz="1400" dirty="0">
-                <a:solidFill>
-                  <a:srgbClr val="595959"/>
-                </a:solidFill>
-              </a:rPr>
-              <a:t>For each segment s:  s.embedding ← MiniLM(s.text)  (384-dimensional)</a:t>
-            </a:r>
-          </a:p>
-          <a:p>
-            <a:pPr marL="457200" indent="-342900">
-              <a:lnSpc>
-                <a:spcPct val="90000"/>
-              </a:lnSpc>
-              <a:spcBef>
-                <a:spcPts val="700"/>
-              </a:spcBef>
-              <a:buFont typeface="+mj-lt"/>
-              <a:buAutoNum type="arabicPeriod"/>
-            </a:pPr>
-            <a:r>
-              <a:rPr lang="en-US" sz="1400" dirty="0">
-                <a:solidFill>
-                  <a:srgbClr val="595959"/>
-                </a:solidFill>
-              </a:rPr>
-              <a:t>J.status ← completed (progress 5 → 25 → 70 → 85 → 100 %); on error J.status ← failed</a:t>
-            </a:r>
-          </a:p>
-        </p:txBody>
-      </p:sp>
-      <p:sp>
-        <p:nvSpPr>
-          <p:cNvPr id="6" name="TextBox 5"/>
-          <p:cNvSpPr txBox="1"/>
-          <p:nvPr/>
-        </p:nvSpPr>
-        <p:spPr>
-          <a:xfrm>
-            <a:off x="822960" y="1920240"/>
-            <a:ext cx="7589520" cy="365760"/>
+            <a:off x="2377440" y="4091940"/>
+            <a:ext cx="4389120" cy="274320"/>
           </a:xfrm>
           <a:prstGeom prst="rect">
             <a:avLst/>
@@ -6030,28 +5943,28 @@
           </a:bodyPr>
           <a:lstStyle/>
           <a:p>
-            <a:pPr algn="l"/>
+            <a:pPr algn="ctr"/>
             <a:r>
-              <a:rPr sz="1400" b="1" i="0">
+              <a:rPr sz="1000" i="1">
                 <a:solidFill>
                   <a:srgbClr val="595959"/>
                 </a:solidFill>
               </a:rPr>
-              <a:t>Transcription with Vani — input: recording R with audio file, dialect D</a:t>
+              <a:t>Recording page: Vani’s transcript, synced with the audio</a:t>
             </a:r>
           </a:p>
         </p:txBody>
       </p:sp>
       <p:sp>
         <p:nvSpPr>
-          <p:cNvPr id="7" name="TextBox 6"/>
+          <p:cNvPr id="10" name="TextBox 9"/>
           <p:cNvSpPr txBox="1"/>
           <p:nvPr/>
         </p:nvSpPr>
         <p:spPr>
           <a:xfrm>
-            <a:off x="822960" y="4846320"/>
-            <a:ext cx="7589520" cy="731520"/>
+            <a:off x="822960" y="4434840"/>
+            <a:ext cx="7589520" cy="2286000"/>
           </a:xfrm>
           <a:prstGeom prst="rect">
             <a:avLst/>
@@ -6064,22 +5977,177 @@
           </a:bodyPr>
           <a:lstStyle/>
           <a:p>
-            <a:pPr algn="l"/>
+            <a:pPr marL="457200" indent="-342900">
+              <a:lnSpc>
+                <a:spcPct val="90000"/>
+              </a:lnSpc>
+              <a:spcBef>
+                <a:spcPts val="500"/>
+              </a:spcBef>
+              <a:buSzPts val="1800"/>
+              <a:buFont typeface="Arial"/>
+              <a:buChar char="•"/>
+            </a:pPr>
             <a:r>
-              <a:rPr sz="1200" b="1">
+              <a:rPr lang="en-US" sz="1400" b="1" dirty="0">
                 <a:solidFill>
                   <a:srgbClr val="595959"/>
                 </a:solidFill>
               </a:rPr>
-              <a:t>Also: </a:t>
+              <a:t>Deployed live: </a:t>
             </a:r>
             <a:r>
-              <a:rPr sz="1200" i="0">
+              <a:rPr lang="en-US" sz="1400" dirty="0">
                 <a:solidFill>
                   <a:srgbClr val="595959"/>
                 </a:solidFill>
               </a:rPr>
-              <a:t>keyword search with PostgreSQL full-text ranking; search by meaning with pgvector cosine distance; corrections are re-embedded; offline recordings wait in IndexedDB and upload when the connection returns.</a:t>
+              <a:t>swara-veda.vercel.app with a FastAPI server on Render and a Supabase database</a:t>
+            </a:r>
+          </a:p>
+          <a:p>
+            <a:pPr marL="457200" indent="-342900">
+              <a:lnSpc>
+                <a:spcPct val="90000"/>
+              </a:lnSpc>
+              <a:spcBef>
+                <a:spcPts val="500"/>
+              </a:spcBef>
+              <a:buSzPts val="1800"/>
+              <a:buFont typeface="Arial"/>
+              <a:buChar char="•"/>
+            </a:pPr>
+            <a:r>
+              <a:rPr lang="en-US" sz="1400" b="1" dirty="0">
+                <a:solidFill>
+                  <a:srgbClr val="595959"/>
+                </a:solidFill>
+              </a:rPr>
+              <a:t>In use: </a:t>
+            </a:r>
+            <a:r>
+              <a:rPr lang="en-US" sz="1400" dirty="0">
+                <a:solidFill>
+                  <a:srgbClr val="595959"/>
+                </a:solidFill>
+              </a:rPr>
+              <a:t>4 recordings and 26 s of speech so far, 1 passage verified by a native speaker</a:t>
+            </a:r>
+          </a:p>
+          <a:p>
+            <a:pPr marL="457200" indent="-342900">
+              <a:lnSpc>
+                <a:spcPct val="90000"/>
+              </a:lnSpc>
+              <a:spcBef>
+                <a:spcPts val="500"/>
+              </a:spcBef>
+              <a:buSzPts val="1800"/>
+              <a:buFont typeface="Arial"/>
+              <a:buChar char="•"/>
+            </a:pPr>
+            <a:r>
+              <a:rPr lang="en-US" sz="1400" b="1" dirty="0">
+                <a:solidFill>
+                  <a:srgbClr val="595959"/>
+                </a:solidFill>
+              </a:rPr>
+              <a:t>140 dialects </a:t>
+            </a:r>
+            <a:r>
+              <a:rPr lang="en-US" sz="1400" dirty="0">
+                <a:solidFill>
+                  <a:srgbClr val="595959"/>
+                </a:solidFill>
+              </a:rPr>
+              <a:t>catalogued with region, script, ISO code and Vani’s language hint</a:t>
+            </a:r>
+          </a:p>
+          <a:p>
+            <a:pPr marL="457200" indent="-342900">
+              <a:lnSpc>
+                <a:spcPct val="90000"/>
+              </a:lnSpc>
+              <a:spcBef>
+                <a:spcPts val="500"/>
+              </a:spcBef>
+              <a:buSzPts val="1800"/>
+              <a:buFont typeface="Arial"/>
+              <a:buChar char="•"/>
+            </a:pPr>
+            <a:r>
+              <a:rPr lang="en-US" sz="1400" b="1" dirty="0">
+                <a:solidFill>
+                  <a:srgbClr val="595959"/>
+                </a:solidFill>
+              </a:rPr>
+              <a:t>110+ automated tests </a:t>
+            </a:r>
+            <a:r>
+              <a:rPr lang="en-US" sz="1400" dirty="0">
+                <a:solidFill>
+                  <a:srgbClr val="595959"/>
+                </a:solidFill>
+              </a:rPr>
+              <a:t>pass, plus tests on real PostgreSQL; end-to-end browser tests show no errors</a:t>
+            </a:r>
+          </a:p>
+          <a:p>
+            <a:pPr marL="457200" indent="-342900">
+              <a:lnSpc>
+                <a:spcPct val="90000"/>
+              </a:lnSpc>
+              <a:spcBef>
+                <a:spcPts val="500"/>
+              </a:spcBef>
+              <a:buSzPts val="1800"/>
+              <a:buFont typeface="Arial"/>
+              <a:buChar char="•"/>
+            </a:pPr>
+            <a:r>
+              <a:rPr lang="en-US" sz="1400" b="1" dirty="0">
+                <a:solidFill>
+                  <a:srgbClr val="595959"/>
+                </a:solidFill>
+              </a:rPr>
+              <a:t>Pre-processing: </a:t>
+            </a:r>
+            <a:r>
+              <a:rPr lang="en-US" sz="1400" dirty="0">
+                <a:solidFill>
+                  <a:srgbClr val="595959"/>
+                </a:solidFill>
+              </a:rPr>
+              <a:t>a 2 MB stereo WAV becomes 24 KB before it is sent to Whisper</a:t>
+            </a:r>
+          </a:p>
+          <a:p>
+            <a:pPr marL="457200" indent="-342900">
+              <a:lnSpc>
+                <a:spcPct val="90000"/>
+              </a:lnSpc>
+              <a:spcBef>
+                <a:spcPts val="500"/>
+              </a:spcBef>
+              <a:buSzPts val="1800"/>
+              <a:buFont typeface="Arial"/>
+              <a:buChar char="•"/>
+            </a:pPr>
+            <a:r>
+              <a:rPr lang="en-US" sz="1400" b="1" dirty="0">
+                <a:solidFill>
+                  <a:srgbClr val="595959"/>
+                </a:solidFill>
+              </a:rPr>
+              <a:t>Works offline: </a:t>
+            </a:r>
+            <a:r>
+              <a:rPr lang="en-US" sz="1400" dirty="0">
+                <a:solidFill>
+                  <a:srgbClr val="595959"/>
+                </a:solidFill>
+              </a:rPr>
+              <a:t>recordings are saved on the device and upload by themselves later</a:t>
             </a:r>
           </a:p>
         </p:txBody>
@@ -6714,1321 +6782,6 @@
           <a:chExt cx="0" cy="0"/>
         </a:xfrm>
       </p:grpSpPr>
-      <p:sp>
-        <p:nvSpPr>
-          <p:cNvPr id="3" name="Google Shape;68;g78e6671419f8a2a0_22">
-            <a:extLst>
-              <a:ext uri="{FF2B5EF4-FFF2-40B4-BE49-F238E27FC236}">
-                <a16:creationId xmlns:a16="http://schemas.microsoft.com/office/drawing/2014/main" id="{BA677A83-D006-E1F4-CCF8-948027C21AB2}"/>
-              </a:ext>
-            </a:extLst>
-          </p:cNvPr>
-          <p:cNvSpPr txBox="1"/>
-          <p:nvPr/>
-        </p:nvSpPr>
-        <p:spPr>
-          <a:xfrm>
-            <a:off x="628650" y="1131097"/>
-            <a:ext cx="7886700" cy="994275"/>
-          </a:xfrm>
-          <a:prstGeom prst="rect">
-            <a:avLst/>
-          </a:prstGeom>
-          <a:noFill/>
-          <a:ln>
-            <a:noFill/>
-          </a:ln>
-        </p:spPr>
-        <p:txBody>
-          <a:bodyPr spcFirstLastPara="1" wrap="square" lIns="68569" tIns="34275" rIns="68569" bIns="34275" anchor="ctr" anchorCtr="0">
-            <a:normAutofit/>
-          </a:bodyPr>
-          <a:lstStyle/>
-          <a:p>
-            <a:pPr algn="ctr" defTabSz="685800">
-              <a:lnSpc>
-                <a:spcPct val="90000"/>
-              </a:lnSpc>
-            </a:pPr>
-            <a:r>
-              <a:rPr lang="en-GB" sz="2400" dirty="0">
-                <a:latin typeface="Times New Roman" panose="02020603050405020304" pitchFamily="18" charset="0"/>
-                <a:cs typeface="Times New Roman" panose="02020603050405020304" pitchFamily="18" charset="0"/>
-              </a:rPr>
-              <a:t>Proposed Model - Methodology (Architecture diagram)</a:t>
-            </a:r>
-            <a:endParaRPr sz="2400" dirty="0">
-              <a:latin typeface="Times New Roman" panose="02020603050405020304" pitchFamily="18" charset="0"/>
-              <a:cs typeface="Times New Roman" panose="02020603050405020304" pitchFamily="18" charset="0"/>
-            </a:endParaRPr>
-          </a:p>
-        </p:txBody>
-      </p:sp>
-      <p:sp>
-        <p:nvSpPr>
-          <p:cNvPr id="4" name="Rounded Rectangle 3"/>
-          <p:cNvSpPr/>
-          <p:nvPr/>
-        </p:nvSpPr>
-        <p:spPr>
-          <a:xfrm>
-            <a:off x="548640" y="2148840"/>
-            <a:ext cx="2331720" cy="868680"/>
-          </a:xfrm>
-          <a:prstGeom prst="roundRect">
-            <a:avLst>
-              <a:gd name="adj" fmla="val 8000"/>
-            </a:avLst>
-          </a:prstGeom>
-          <a:solidFill>
-            <a:srgbClr val="FFFFFF"/>
-          </a:solidFill>
-          <a:ln w="12700">
-            <a:solidFill>
-              <a:srgbClr val="8C8C8C"/>
-            </a:solidFill>
-          </a:ln>
-          <a:effectLst/>
-        </p:spPr>
-        <p:style>
-          <a:lnRef idx="1">
-            <a:schemeClr val="accent1"/>
-          </a:lnRef>
-          <a:fillRef idx="3">
-            <a:schemeClr val="accent1"/>
-          </a:fillRef>
-          <a:effectRef idx="2">
-            <a:schemeClr val="accent1"/>
-          </a:effectRef>
-          <a:fontRef idx="minor">
-            <a:schemeClr val="lt1"/>
-          </a:fontRef>
-        </p:style>
-        <p:txBody>
-          <a:bodyPr wrap="square" lIns="54864" rIns="54864" rtlCol="0" anchor="ctr"/>
-          <a:lstStyle/>
-          <a:p>
-            <a:pPr algn="ctr"/>
-            <a:r>
-              <a:rPr sz="1100" b="1">
-                <a:solidFill>
-                  <a:srgbClr val="262626"/>
-                </a:solidFill>
-              </a:rPr>
-              <a:t>Web client</a:t>
-            </a:r>
-          </a:p>
-          <a:p>
-            <a:pPr algn="ctr"/>
-            <a:r>
-              <a:rPr sz="850">
-                <a:solidFill>
-                  <a:srgbClr val="595959"/>
-                </a:solidFill>
-              </a:rPr>
-              <a:t>React + TypeScript, Vercel
-recording, offline queue</a:t>
-            </a:r>
-          </a:p>
-        </p:txBody>
-      </p:sp>
-      <p:sp>
-        <p:nvSpPr>
-          <p:cNvPr id="5" name="Rounded Rectangle 4"/>
-          <p:cNvSpPr/>
-          <p:nvPr/>
-        </p:nvSpPr>
-        <p:spPr>
-          <a:xfrm>
-            <a:off x="3401568" y="2148840"/>
-            <a:ext cx="2331720" cy="868680"/>
-          </a:xfrm>
-          <a:prstGeom prst="roundRect">
-            <a:avLst>
-              <a:gd name="adj" fmla="val 8000"/>
-            </a:avLst>
-          </a:prstGeom>
-          <a:solidFill>
-            <a:srgbClr val="FFFFFF"/>
-          </a:solidFill>
-          <a:ln w="12700">
-            <a:solidFill>
-              <a:srgbClr val="8C8C8C"/>
-            </a:solidFill>
-          </a:ln>
-          <a:effectLst/>
-        </p:spPr>
-        <p:style>
-          <a:lnRef idx="1">
-            <a:schemeClr val="accent1"/>
-          </a:lnRef>
-          <a:fillRef idx="3">
-            <a:schemeClr val="accent1"/>
-          </a:fillRef>
-          <a:effectRef idx="2">
-            <a:schemeClr val="accent1"/>
-          </a:effectRef>
-          <a:fontRef idx="minor">
-            <a:schemeClr val="lt1"/>
-          </a:fontRef>
-        </p:style>
-        <p:txBody>
-          <a:bodyPr wrap="square" lIns="54864" rIns="54864" rtlCol="0" anchor="ctr"/>
-          <a:lstStyle/>
-          <a:p>
-            <a:pPr algn="ctr"/>
-            <a:r>
-              <a:rPr sz="1100" b="1">
-                <a:solidFill>
-                  <a:srgbClr val="262626"/>
-                </a:solidFill>
-              </a:rPr>
-              <a:t>REST API (FastAPI)</a:t>
-            </a:r>
-          </a:p>
-          <a:p>
-            <a:pPr algn="ctr"/>
-            <a:r>
-              <a:rPr sz="850">
-                <a:solidFill>
-                  <a:srgbClr val="595959"/>
-                </a:solidFill>
-              </a:rPr>
-              <a:t>auth, recordings, review,
-search, export • Render</a:t>
-            </a:r>
-          </a:p>
-        </p:txBody>
-      </p:sp>
-      <p:sp>
-        <p:nvSpPr>
-          <p:cNvPr id="6" name="Rounded Rectangle 5"/>
-          <p:cNvSpPr/>
-          <p:nvPr/>
-        </p:nvSpPr>
-        <p:spPr>
-          <a:xfrm>
-            <a:off x="6254496" y="2148840"/>
-            <a:ext cx="2331720" cy="868680"/>
-          </a:xfrm>
-          <a:prstGeom prst="roundRect">
-            <a:avLst>
-              <a:gd name="adj" fmla="val 8000"/>
-            </a:avLst>
-          </a:prstGeom>
-          <a:solidFill>
-            <a:srgbClr val="FFFFFF"/>
-          </a:solidFill>
-          <a:ln w="12700">
-            <a:solidFill>
-              <a:srgbClr val="8C8C8C"/>
-            </a:solidFill>
-          </a:ln>
-          <a:effectLst/>
-        </p:spPr>
-        <p:style>
-          <a:lnRef idx="1">
-            <a:schemeClr val="accent1"/>
-          </a:lnRef>
-          <a:fillRef idx="3">
-            <a:schemeClr val="accent1"/>
-          </a:fillRef>
-          <a:effectRef idx="2">
-            <a:schemeClr val="accent1"/>
-          </a:effectRef>
-          <a:fontRef idx="minor">
-            <a:schemeClr val="lt1"/>
-          </a:fontRef>
-        </p:style>
-        <p:txBody>
-          <a:bodyPr wrap="square" lIns="54864" rIns="54864" rtlCol="0" anchor="ctr"/>
-          <a:lstStyle/>
-          <a:p>
-            <a:pPr algn="ctr"/>
-            <a:r>
-              <a:rPr sz="1100" b="1">
-                <a:solidFill>
-                  <a:srgbClr val="262626"/>
-                </a:solidFill>
-              </a:rPr>
-              <a:t>Vani AI services</a:t>
-            </a:r>
-          </a:p>
-          <a:p>
-            <a:pPr algn="ctr"/>
-            <a:r>
-              <a:rPr sz="850">
-                <a:solidFill>
-                  <a:srgbClr val="595959"/>
-                </a:solidFill>
-              </a:rPr>
-              <a:t>Whisper large-v3 (speech)
-Llama 3.3 • MiniLM embeddings</a:t>
-            </a:r>
-          </a:p>
-        </p:txBody>
-      </p:sp>
-      <p:sp>
-        <p:nvSpPr>
-          <p:cNvPr id="7" name="Rounded Rectangle 6"/>
-          <p:cNvSpPr/>
-          <p:nvPr/>
-        </p:nvSpPr>
-        <p:spPr>
-          <a:xfrm>
-            <a:off x="548640" y="3703320"/>
-            <a:ext cx="2331720" cy="868680"/>
-          </a:xfrm>
-          <a:prstGeom prst="roundRect">
-            <a:avLst>
-              <a:gd name="adj" fmla="val 8000"/>
-            </a:avLst>
-          </a:prstGeom>
-          <a:solidFill>
-            <a:srgbClr val="FFFFFF"/>
-          </a:solidFill>
-          <a:ln w="12700">
-            <a:solidFill>
-              <a:srgbClr val="8C8C8C"/>
-            </a:solidFill>
-          </a:ln>
-          <a:effectLst/>
-        </p:spPr>
-        <p:style>
-          <a:lnRef idx="1">
-            <a:schemeClr val="accent1"/>
-          </a:lnRef>
-          <a:fillRef idx="3">
-            <a:schemeClr val="accent1"/>
-          </a:fillRef>
-          <a:effectRef idx="2">
-            <a:schemeClr val="accent1"/>
-          </a:effectRef>
-          <a:fontRef idx="minor">
-            <a:schemeClr val="lt1"/>
-          </a:fontRef>
-        </p:style>
-        <p:txBody>
-          <a:bodyPr wrap="square" lIns="54864" rIns="54864" rtlCol="0" anchor="ctr"/>
-          <a:lstStyle/>
-          <a:p>
-            <a:pPr algn="ctr"/>
-            <a:r>
-              <a:rPr sz="1100" b="1">
-                <a:solidFill>
-                  <a:srgbClr val="262626"/>
-                </a:solidFill>
-              </a:rPr>
-              <a:t>Object storage</a:t>
-            </a:r>
-          </a:p>
-          <a:p>
-            <a:pPr algn="ctr"/>
-            <a:r>
-              <a:rPr sz="850">
-                <a:solidFill>
-                  <a:srgbClr val="595959"/>
-                </a:solidFill>
-              </a:rPr>
-              <a:t>Supabase Storage
-audio files</a:t>
-            </a:r>
-          </a:p>
-        </p:txBody>
-      </p:sp>
-      <p:sp>
-        <p:nvSpPr>
-          <p:cNvPr id="8" name="Rounded Rectangle 7"/>
-          <p:cNvSpPr/>
-          <p:nvPr/>
-        </p:nvSpPr>
-        <p:spPr>
-          <a:xfrm>
-            <a:off x="3401568" y="3703320"/>
-            <a:ext cx="2331720" cy="868680"/>
-          </a:xfrm>
-          <a:prstGeom prst="roundRect">
-            <a:avLst>
-              <a:gd name="adj" fmla="val 8000"/>
-            </a:avLst>
-          </a:prstGeom>
-          <a:solidFill>
-            <a:srgbClr val="FFFFFF"/>
-          </a:solidFill>
-          <a:ln w="12700">
-            <a:solidFill>
-              <a:srgbClr val="8C8C8C"/>
-            </a:solidFill>
-          </a:ln>
-          <a:effectLst/>
-        </p:spPr>
-        <p:style>
-          <a:lnRef idx="1">
-            <a:schemeClr val="accent1"/>
-          </a:lnRef>
-          <a:fillRef idx="3">
-            <a:schemeClr val="accent1"/>
-          </a:fillRef>
-          <a:effectRef idx="2">
-            <a:schemeClr val="accent1"/>
-          </a:effectRef>
-          <a:fontRef idx="minor">
-            <a:schemeClr val="lt1"/>
-          </a:fontRef>
-        </p:style>
-        <p:txBody>
-          <a:bodyPr wrap="square" lIns="54864" rIns="54864" rtlCol="0" anchor="ctr"/>
-          <a:lstStyle/>
-          <a:p>
-            <a:pPr algn="ctr"/>
-            <a:r>
-              <a:rPr sz="1100" b="1">
-                <a:solidFill>
-                  <a:srgbClr val="262626"/>
-                </a:solidFill>
-              </a:rPr>
-              <a:t>Database</a:t>
-            </a:r>
-          </a:p>
-          <a:p>
-            <a:pPr algn="ctr"/>
-            <a:r>
-              <a:rPr sz="850">
-                <a:solidFill>
-                  <a:srgbClr val="595959"/>
-                </a:solidFill>
-              </a:rPr>
-              <a:t>PostgreSQL + pgvector
-(Supabase)</a:t>
-            </a:r>
-          </a:p>
-        </p:txBody>
-      </p:sp>
-      <p:sp>
-        <p:nvSpPr>
-          <p:cNvPr id="9" name="Rounded Rectangle 8"/>
-          <p:cNvSpPr/>
-          <p:nvPr/>
-        </p:nvSpPr>
-        <p:spPr>
-          <a:xfrm>
-            <a:off x="6254496" y="3703320"/>
-            <a:ext cx="2331720" cy="868680"/>
-          </a:xfrm>
-          <a:prstGeom prst="roundRect">
-            <a:avLst>
-              <a:gd name="adj" fmla="val 8000"/>
-            </a:avLst>
-          </a:prstGeom>
-          <a:solidFill>
-            <a:srgbClr val="FFFFFF"/>
-          </a:solidFill>
-          <a:ln w="12700">
-            <a:solidFill>
-              <a:srgbClr val="8C8C8C"/>
-            </a:solidFill>
-          </a:ln>
-          <a:effectLst/>
-        </p:spPr>
-        <p:style>
-          <a:lnRef idx="1">
-            <a:schemeClr val="accent1"/>
-          </a:lnRef>
-          <a:fillRef idx="3">
-            <a:schemeClr val="accent1"/>
-          </a:fillRef>
-          <a:effectRef idx="2">
-            <a:schemeClr val="accent1"/>
-          </a:effectRef>
-          <a:fontRef idx="minor">
-            <a:schemeClr val="lt1"/>
-          </a:fontRef>
-        </p:style>
-        <p:txBody>
-          <a:bodyPr wrap="square" lIns="54864" rIns="54864" rtlCol="0" anchor="ctr"/>
-          <a:lstStyle/>
-          <a:p>
-            <a:pPr algn="ctr"/>
-            <a:r>
-              <a:rPr sz="1100" b="1">
-                <a:solidFill>
-                  <a:srgbClr val="262626"/>
-                </a:solidFill>
-              </a:rPr>
-              <a:t>Audio pre-processing</a:t>
-            </a:r>
-          </a:p>
-          <a:p>
-            <a:pPr algn="ctr"/>
-            <a:r>
-              <a:rPr sz="850">
-                <a:solidFill>
-                  <a:srgbClr val="595959"/>
-                </a:solidFill>
-              </a:rPr>
-              <a:t>ffmpeg: 16 kHz mono,
-high-pass, loudness</a:t>
-            </a:r>
-          </a:p>
-        </p:txBody>
-      </p:sp>
-      <p:cxnSp>
-        <p:nvCxnSpPr>
-          <p:cNvPr id="10" name="Connector 9"/>
-          <p:cNvCxnSpPr/>
-          <p:nvPr/>
-        </p:nvCxnSpPr>
-        <p:spPr>
-          <a:xfrm>
-            <a:off x="2880360" y="2578608"/>
-            <a:ext cx="521208" cy="0"/>
-          </a:xfrm>
-          <a:prstGeom prst="line">
-            <a:avLst/>
-          </a:prstGeom>
-          <a:ln w="15875">
-            <a:solidFill>
-              <a:srgbClr val="8C8C8C"/>
-            </a:solidFill>
-            <a:tailEnd type="triangle" w="med" len="med"/>
-          </a:ln>
-        </p:spPr>
-        <p:style>
-          <a:lnRef idx="2">
-            <a:schemeClr val="accent1"/>
-          </a:lnRef>
-          <a:fillRef idx="0">
-            <a:schemeClr val="accent1"/>
-          </a:fillRef>
-          <a:effectRef idx="1">
-            <a:schemeClr val="accent1"/>
-          </a:effectRef>
-          <a:fontRef idx="minor">
-            <a:schemeClr val="tx1"/>
-          </a:fontRef>
-        </p:style>
-      </p:cxnSp>
-      <p:sp>
-        <p:nvSpPr>
-          <p:cNvPr id="11" name="TextBox 10"/>
-          <p:cNvSpPr txBox="1"/>
-          <p:nvPr/>
-        </p:nvSpPr>
-        <p:spPr>
-          <a:xfrm>
-            <a:off x="2743200" y="2286000"/>
-            <a:ext cx="1188720" cy="228600"/>
-          </a:xfrm>
-          <a:prstGeom prst="rect">
-            <a:avLst/>
-          </a:prstGeom>
-          <a:noFill/>
-        </p:spPr>
-        <p:txBody>
-          <a:bodyPr wrap="square">
-            <a:spAutoFit/>
-          </a:bodyPr>
-          <a:lstStyle/>
-          <a:p>
-            <a:pPr algn="l"/>
-            <a:r>
-              <a:rPr sz="800" i="1">
-                <a:solidFill>
-                  <a:srgbClr val="595959"/>
-                </a:solidFill>
-              </a:rPr>
-              <a:t>REST + JWT</a:t>
-            </a:r>
-          </a:p>
-        </p:txBody>
-      </p:sp>
-      <p:cxnSp>
-        <p:nvCxnSpPr>
-          <p:cNvPr id="12" name="Connector 11"/>
-          <p:cNvCxnSpPr/>
-          <p:nvPr/>
-        </p:nvCxnSpPr>
-        <p:spPr>
-          <a:xfrm>
-            <a:off x="5733288" y="2578608"/>
-            <a:ext cx="521208" cy="0"/>
-          </a:xfrm>
-          <a:prstGeom prst="line">
-            <a:avLst/>
-          </a:prstGeom>
-          <a:ln w="15875">
-            <a:solidFill>
-              <a:srgbClr val="8C8C8C"/>
-            </a:solidFill>
-            <a:tailEnd type="triangle" w="med" len="med"/>
-          </a:ln>
-        </p:spPr>
-        <p:style>
-          <a:lnRef idx="2">
-            <a:schemeClr val="accent1"/>
-          </a:lnRef>
-          <a:fillRef idx="0">
-            <a:schemeClr val="accent1"/>
-          </a:fillRef>
-          <a:effectRef idx="1">
-            <a:schemeClr val="accent1"/>
-          </a:effectRef>
-          <a:fontRef idx="minor">
-            <a:schemeClr val="tx1"/>
-          </a:fontRef>
-        </p:style>
-      </p:cxnSp>
-      <p:sp>
-        <p:nvSpPr>
-          <p:cNvPr id="13" name="TextBox 12"/>
-          <p:cNvSpPr txBox="1"/>
-          <p:nvPr/>
-        </p:nvSpPr>
-        <p:spPr>
-          <a:xfrm>
-            <a:off x="5577840" y="2286000"/>
-            <a:ext cx="1188720" cy="228600"/>
-          </a:xfrm>
-          <a:prstGeom prst="rect">
-            <a:avLst/>
-          </a:prstGeom>
-          <a:noFill/>
-        </p:spPr>
-        <p:txBody>
-          <a:bodyPr wrap="square">
-            <a:spAutoFit/>
-          </a:bodyPr>
-          <a:lstStyle/>
-          <a:p>
-            <a:pPr algn="l"/>
-            <a:r>
-              <a:rPr sz="800" i="1">
-                <a:solidFill>
-                  <a:srgbClr val="595959"/>
-                </a:solidFill>
-              </a:rPr>
-              <a:t>audio, text</a:t>
-            </a:r>
-          </a:p>
-        </p:txBody>
-      </p:sp>
-      <p:cxnSp>
-        <p:nvCxnSpPr>
-          <p:cNvPr id="14" name="Connector 13"/>
-          <p:cNvCxnSpPr/>
-          <p:nvPr/>
-        </p:nvCxnSpPr>
-        <p:spPr>
-          <a:xfrm>
-            <a:off x="1719072" y="3017520"/>
-            <a:ext cx="0" cy="685800"/>
-          </a:xfrm>
-          <a:prstGeom prst="line">
-            <a:avLst/>
-          </a:prstGeom>
-          <a:ln w="15875">
-            <a:solidFill>
-              <a:srgbClr val="8C8C8C"/>
-            </a:solidFill>
-            <a:tailEnd type="triangle" w="med" len="med"/>
-          </a:ln>
-        </p:spPr>
-        <p:style>
-          <a:lnRef idx="2">
-            <a:schemeClr val="accent1"/>
-          </a:lnRef>
-          <a:fillRef idx="0">
-            <a:schemeClr val="accent1"/>
-          </a:fillRef>
-          <a:effectRef idx="1">
-            <a:schemeClr val="accent1"/>
-          </a:effectRef>
-          <a:fontRef idx="minor">
-            <a:schemeClr val="tx1"/>
-          </a:fontRef>
-        </p:style>
-      </p:cxnSp>
-      <p:sp>
-        <p:nvSpPr>
-          <p:cNvPr id="15" name="TextBox 14"/>
-          <p:cNvSpPr txBox="1"/>
-          <p:nvPr/>
-        </p:nvSpPr>
-        <p:spPr>
-          <a:xfrm>
-            <a:off x="1783080" y="3246120"/>
-            <a:ext cx="1188720" cy="228600"/>
-          </a:xfrm>
-          <a:prstGeom prst="rect">
-            <a:avLst/>
-          </a:prstGeom>
-          <a:noFill/>
-        </p:spPr>
-        <p:txBody>
-          <a:bodyPr wrap="square">
-            <a:spAutoFit/>
-          </a:bodyPr>
-          <a:lstStyle/>
-          <a:p>
-            <a:pPr algn="l"/>
-            <a:r>
-              <a:rPr sz="800" i="1">
-                <a:solidFill>
-                  <a:srgbClr val="595959"/>
-                </a:solidFill>
-              </a:rPr>
-              <a:t>signed upload</a:t>
-            </a:r>
-          </a:p>
-        </p:txBody>
-      </p:sp>
-      <p:cxnSp>
-        <p:nvCxnSpPr>
-          <p:cNvPr id="16" name="Connector 15"/>
-          <p:cNvCxnSpPr/>
-          <p:nvPr/>
-        </p:nvCxnSpPr>
-        <p:spPr>
-          <a:xfrm>
-            <a:off x="4572000" y="3017520"/>
-            <a:ext cx="0" cy="685800"/>
-          </a:xfrm>
-          <a:prstGeom prst="line">
-            <a:avLst/>
-          </a:prstGeom>
-          <a:ln w="15875">
-            <a:solidFill>
-              <a:srgbClr val="8C8C8C"/>
-            </a:solidFill>
-            <a:tailEnd type="triangle" w="med" len="med"/>
-          </a:ln>
-        </p:spPr>
-        <p:style>
-          <a:lnRef idx="2">
-            <a:schemeClr val="accent1"/>
-          </a:lnRef>
-          <a:fillRef idx="0">
-            <a:schemeClr val="accent1"/>
-          </a:fillRef>
-          <a:effectRef idx="1">
-            <a:schemeClr val="accent1"/>
-          </a:effectRef>
-          <a:fontRef idx="minor">
-            <a:schemeClr val="tx1"/>
-          </a:fontRef>
-        </p:style>
-      </p:cxnSp>
-      <p:sp>
-        <p:nvSpPr>
-          <p:cNvPr id="17" name="TextBox 16"/>
-          <p:cNvSpPr txBox="1"/>
-          <p:nvPr/>
-        </p:nvSpPr>
-        <p:spPr>
-          <a:xfrm>
-            <a:off x="4636008" y="3246120"/>
-            <a:ext cx="1188720" cy="228600"/>
-          </a:xfrm>
-          <a:prstGeom prst="rect">
-            <a:avLst/>
-          </a:prstGeom>
-          <a:noFill/>
-        </p:spPr>
-        <p:txBody>
-          <a:bodyPr wrap="square">
-            <a:spAutoFit/>
-          </a:bodyPr>
-          <a:lstStyle/>
-          <a:p>
-            <a:pPr algn="l"/>
-            <a:r>
-              <a:rPr sz="800" i="1">
-                <a:solidFill>
-                  <a:srgbClr val="595959"/>
-                </a:solidFill>
-              </a:rPr>
-              <a:t>SQL</a:t>
-            </a:r>
-          </a:p>
-        </p:txBody>
-      </p:sp>
-      <p:cxnSp>
-        <p:nvCxnSpPr>
-          <p:cNvPr id="18" name="Connector 17"/>
-          <p:cNvCxnSpPr/>
-          <p:nvPr/>
-        </p:nvCxnSpPr>
-        <p:spPr>
-          <a:xfrm>
-            <a:off x="5733288" y="2834640"/>
-            <a:ext cx="521208" cy="1097280"/>
-          </a:xfrm>
-          <a:prstGeom prst="line">
-            <a:avLst/>
-          </a:prstGeom>
-          <a:ln w="15875">
-            <a:solidFill>
-              <a:srgbClr val="8C8C8C"/>
-            </a:solidFill>
-            <a:tailEnd type="triangle" w="med" len="med"/>
-          </a:ln>
-        </p:spPr>
-        <p:style>
-          <a:lnRef idx="2">
-            <a:schemeClr val="accent1"/>
-          </a:lnRef>
-          <a:fillRef idx="0">
-            <a:schemeClr val="accent1"/>
-          </a:fillRef>
-          <a:effectRef idx="1">
-            <a:schemeClr val="accent1"/>
-          </a:effectRef>
-          <a:fontRef idx="minor">
-            <a:schemeClr val="tx1"/>
-          </a:fontRef>
-        </p:style>
-      </p:cxnSp>
-      <p:sp>
-        <p:nvSpPr>
-          <p:cNvPr id="19" name="Rounded Rectangle 18"/>
-          <p:cNvSpPr/>
-          <p:nvPr/>
-        </p:nvSpPr>
-        <p:spPr>
-          <a:xfrm>
-            <a:off x="548640" y="5074920"/>
-            <a:ext cx="1133856" cy="658368"/>
-          </a:xfrm>
-          <a:prstGeom prst="roundRect">
-            <a:avLst/>
-          </a:prstGeom>
-          <a:solidFill>
-            <a:srgbClr val="F2F2F2"/>
-          </a:solidFill>
-          <a:ln w="9525">
-            <a:solidFill>
-              <a:srgbClr val="8C8C8C"/>
-            </a:solidFill>
-          </a:ln>
-          <a:effectLst/>
-        </p:spPr>
-        <p:style>
-          <a:lnRef idx="1">
-            <a:schemeClr val="accent1"/>
-          </a:lnRef>
-          <a:fillRef idx="3">
-            <a:schemeClr val="accent1"/>
-          </a:fillRef>
-          <a:effectRef idx="2">
-            <a:schemeClr val="accent1"/>
-          </a:effectRef>
-          <a:fontRef idx="minor">
-            <a:schemeClr val="lt1"/>
-          </a:fontRef>
-        </p:style>
-        <p:txBody>
-          <a:bodyPr wrap="square" rtlCol="0" anchor="ctr"/>
-          <a:lstStyle/>
-          <a:p>
-            <a:pPr algn="ctr"/>
-            <a:r>
-              <a:rPr sz="1000">
-                <a:solidFill>
-                  <a:srgbClr val="262626"/>
-                </a:solidFill>
-              </a:rPr>
-              <a:t>1. Record &amp;
-consent</a:t>
-            </a:r>
-          </a:p>
-        </p:txBody>
-      </p:sp>
-      <p:cxnSp>
-        <p:nvCxnSpPr>
-          <p:cNvPr id="20" name="Connector 19"/>
-          <p:cNvCxnSpPr/>
-          <p:nvPr/>
-        </p:nvCxnSpPr>
-        <p:spPr>
-          <a:xfrm>
-            <a:off x="1682495" y="5404104"/>
-            <a:ext cx="219457" cy="0"/>
-          </a:xfrm>
-          <a:prstGeom prst="line">
-            <a:avLst/>
-          </a:prstGeom>
-          <a:ln w="15875">
-            <a:solidFill>
-              <a:srgbClr val="8C8C8C"/>
-            </a:solidFill>
-            <a:tailEnd type="triangle" w="med" len="med"/>
-          </a:ln>
-        </p:spPr>
-        <p:style>
-          <a:lnRef idx="2">
-            <a:schemeClr val="accent1"/>
-          </a:lnRef>
-          <a:fillRef idx="0">
-            <a:schemeClr val="accent1"/>
-          </a:fillRef>
-          <a:effectRef idx="1">
-            <a:schemeClr val="accent1"/>
-          </a:effectRef>
-          <a:fontRef idx="minor">
-            <a:schemeClr val="tx1"/>
-          </a:fontRef>
-        </p:style>
-      </p:cxnSp>
-      <p:sp>
-        <p:nvSpPr>
-          <p:cNvPr id="21" name="Rounded Rectangle 20"/>
-          <p:cNvSpPr/>
-          <p:nvPr/>
-        </p:nvSpPr>
-        <p:spPr>
-          <a:xfrm>
-            <a:off x="1901952" y="5074920"/>
-            <a:ext cx="1133856" cy="658368"/>
-          </a:xfrm>
-          <a:prstGeom prst="roundRect">
-            <a:avLst/>
-          </a:prstGeom>
-          <a:solidFill>
-            <a:srgbClr val="F2F2F2"/>
-          </a:solidFill>
-          <a:ln w="9525">
-            <a:solidFill>
-              <a:srgbClr val="8C8C8C"/>
-            </a:solidFill>
-          </a:ln>
-          <a:effectLst/>
-        </p:spPr>
-        <p:style>
-          <a:lnRef idx="1">
-            <a:schemeClr val="accent1"/>
-          </a:lnRef>
-          <a:fillRef idx="3">
-            <a:schemeClr val="accent1"/>
-          </a:fillRef>
-          <a:effectRef idx="2">
-            <a:schemeClr val="accent1"/>
-          </a:effectRef>
-          <a:fontRef idx="minor">
-            <a:schemeClr val="lt1"/>
-          </a:fontRef>
-        </p:style>
-        <p:txBody>
-          <a:bodyPr wrap="square" rtlCol="0" anchor="ctr"/>
-          <a:lstStyle/>
-          <a:p>
-            <a:pPr algn="ctr"/>
-            <a:r>
-              <a:rPr sz="1000">
-                <a:solidFill>
-                  <a:srgbClr val="262626"/>
-                </a:solidFill>
-              </a:rPr>
-              <a:t>2. Pre-process</a:t>
-            </a:r>
-          </a:p>
-        </p:txBody>
-      </p:sp>
-      <p:cxnSp>
-        <p:nvCxnSpPr>
-          <p:cNvPr id="22" name="Connector 21"/>
-          <p:cNvCxnSpPr/>
-          <p:nvPr/>
-        </p:nvCxnSpPr>
-        <p:spPr>
-          <a:xfrm>
-            <a:off x="3035808" y="5404104"/>
-            <a:ext cx="219456" cy="0"/>
-          </a:xfrm>
-          <a:prstGeom prst="line">
-            <a:avLst/>
-          </a:prstGeom>
-          <a:ln w="15875">
-            <a:solidFill>
-              <a:srgbClr val="8C8C8C"/>
-            </a:solidFill>
-            <a:tailEnd type="triangle" w="med" len="med"/>
-          </a:ln>
-        </p:spPr>
-        <p:style>
-          <a:lnRef idx="2">
-            <a:schemeClr val="accent1"/>
-          </a:lnRef>
-          <a:fillRef idx="0">
-            <a:schemeClr val="accent1"/>
-          </a:fillRef>
-          <a:effectRef idx="1">
-            <a:schemeClr val="accent1"/>
-          </a:effectRef>
-          <a:fontRef idx="minor">
-            <a:schemeClr val="tx1"/>
-          </a:fontRef>
-        </p:style>
-      </p:cxnSp>
-      <p:sp>
-        <p:nvSpPr>
-          <p:cNvPr id="23" name="Rounded Rectangle 22"/>
-          <p:cNvSpPr/>
-          <p:nvPr/>
-        </p:nvSpPr>
-        <p:spPr>
-          <a:xfrm>
-            <a:off x="3255264" y="5074920"/>
-            <a:ext cx="1133856" cy="658368"/>
-          </a:xfrm>
-          <a:prstGeom prst="roundRect">
-            <a:avLst/>
-          </a:prstGeom>
-          <a:solidFill>
-            <a:srgbClr val="F2F2F2"/>
-          </a:solidFill>
-          <a:ln w="9525">
-            <a:solidFill>
-              <a:srgbClr val="8C8C8C"/>
-            </a:solidFill>
-          </a:ln>
-          <a:effectLst/>
-        </p:spPr>
-        <p:style>
-          <a:lnRef idx="1">
-            <a:schemeClr val="accent1"/>
-          </a:lnRef>
-          <a:fillRef idx="3">
-            <a:schemeClr val="accent1"/>
-          </a:fillRef>
-          <a:effectRef idx="2">
-            <a:schemeClr val="accent1"/>
-          </a:effectRef>
-          <a:fontRef idx="minor">
-            <a:schemeClr val="lt1"/>
-          </a:fontRef>
-        </p:style>
-        <p:txBody>
-          <a:bodyPr wrap="square" rtlCol="0" anchor="ctr"/>
-          <a:lstStyle/>
-          <a:p>
-            <a:pPr algn="ctr"/>
-            <a:r>
-              <a:rPr sz="1000">
-                <a:solidFill>
-                  <a:srgbClr val="262626"/>
-                </a:solidFill>
-              </a:rPr>
-              <a:t>3. Transcribe
-(Vani)</a:t>
-            </a:r>
-          </a:p>
-        </p:txBody>
-      </p:sp>
-      <p:cxnSp>
-        <p:nvCxnSpPr>
-          <p:cNvPr id="24" name="Connector 23"/>
-          <p:cNvCxnSpPr/>
-          <p:nvPr/>
-        </p:nvCxnSpPr>
-        <p:spPr>
-          <a:xfrm>
-            <a:off x="4389120" y="5404104"/>
-            <a:ext cx="219456" cy="0"/>
-          </a:xfrm>
-          <a:prstGeom prst="line">
-            <a:avLst/>
-          </a:prstGeom>
-          <a:ln w="15875">
-            <a:solidFill>
-              <a:srgbClr val="8C8C8C"/>
-            </a:solidFill>
-            <a:tailEnd type="triangle" w="med" len="med"/>
-          </a:ln>
-        </p:spPr>
-        <p:style>
-          <a:lnRef idx="2">
-            <a:schemeClr val="accent1"/>
-          </a:lnRef>
-          <a:fillRef idx="0">
-            <a:schemeClr val="accent1"/>
-          </a:fillRef>
-          <a:effectRef idx="1">
-            <a:schemeClr val="accent1"/>
-          </a:effectRef>
-          <a:fontRef idx="minor">
-            <a:schemeClr val="tx1"/>
-          </a:fontRef>
-        </p:style>
-      </p:cxnSp>
-      <p:sp>
-        <p:nvSpPr>
-          <p:cNvPr id="25" name="Rounded Rectangle 24"/>
-          <p:cNvSpPr/>
-          <p:nvPr/>
-        </p:nvSpPr>
-        <p:spPr>
-          <a:xfrm>
-            <a:off x="4608576" y="5074920"/>
-            <a:ext cx="1133856" cy="658368"/>
-          </a:xfrm>
-          <a:prstGeom prst="roundRect">
-            <a:avLst/>
-          </a:prstGeom>
-          <a:solidFill>
-            <a:srgbClr val="F2F2F2"/>
-          </a:solidFill>
-          <a:ln w="9525">
-            <a:solidFill>
-              <a:srgbClr val="8C8C8C"/>
-            </a:solidFill>
-          </a:ln>
-          <a:effectLst/>
-        </p:spPr>
-        <p:style>
-          <a:lnRef idx="1">
-            <a:schemeClr val="accent1"/>
-          </a:lnRef>
-          <a:fillRef idx="3">
-            <a:schemeClr val="accent1"/>
-          </a:fillRef>
-          <a:effectRef idx="2">
-            <a:schemeClr val="accent1"/>
-          </a:effectRef>
-          <a:fontRef idx="minor">
-            <a:schemeClr val="lt1"/>
-          </a:fontRef>
-        </p:style>
-        <p:txBody>
-          <a:bodyPr wrap="square" rtlCol="0" anchor="ctr"/>
-          <a:lstStyle/>
-          <a:p>
-            <a:pPr algn="ctr"/>
-            <a:r>
-              <a:rPr sz="1000">
-                <a:solidFill>
-                  <a:srgbClr val="262626"/>
-                </a:solidFill>
-              </a:rPr>
-              <a:t>4. Correct</a:t>
-            </a:r>
-          </a:p>
-        </p:txBody>
-      </p:sp>
-      <p:cxnSp>
-        <p:nvCxnSpPr>
-          <p:cNvPr id="26" name="Connector 25"/>
-          <p:cNvCxnSpPr/>
-          <p:nvPr/>
-        </p:nvCxnSpPr>
-        <p:spPr>
-          <a:xfrm>
-            <a:off x="5742432" y="5404104"/>
-            <a:ext cx="219456" cy="0"/>
-          </a:xfrm>
-          <a:prstGeom prst="line">
-            <a:avLst/>
-          </a:prstGeom>
-          <a:ln w="15875">
-            <a:solidFill>
-              <a:srgbClr val="8C8C8C"/>
-            </a:solidFill>
-            <a:tailEnd type="triangle" w="med" len="med"/>
-          </a:ln>
-        </p:spPr>
-        <p:style>
-          <a:lnRef idx="2">
-            <a:schemeClr val="accent1"/>
-          </a:lnRef>
-          <a:fillRef idx="0">
-            <a:schemeClr val="accent1"/>
-          </a:fillRef>
-          <a:effectRef idx="1">
-            <a:schemeClr val="accent1"/>
-          </a:effectRef>
-          <a:fontRef idx="minor">
-            <a:schemeClr val="tx1"/>
-          </a:fontRef>
-        </p:style>
-      </p:cxnSp>
-      <p:sp>
-        <p:nvSpPr>
-          <p:cNvPr id="27" name="Rounded Rectangle 26"/>
-          <p:cNvSpPr/>
-          <p:nvPr/>
-        </p:nvSpPr>
-        <p:spPr>
-          <a:xfrm>
-            <a:off x="5961888" y="5074920"/>
-            <a:ext cx="1133856" cy="658368"/>
-          </a:xfrm>
-          <a:prstGeom prst="roundRect">
-            <a:avLst/>
-          </a:prstGeom>
-          <a:solidFill>
-            <a:srgbClr val="F2F2F2"/>
-          </a:solidFill>
-          <a:ln w="9525">
-            <a:solidFill>
-              <a:srgbClr val="8C8C8C"/>
-            </a:solidFill>
-          </a:ln>
-          <a:effectLst/>
-        </p:spPr>
-        <p:style>
-          <a:lnRef idx="1">
-            <a:schemeClr val="accent1"/>
-          </a:lnRef>
-          <a:fillRef idx="3">
-            <a:schemeClr val="accent1"/>
-          </a:fillRef>
-          <a:effectRef idx="2">
-            <a:schemeClr val="accent1"/>
-          </a:effectRef>
-          <a:fontRef idx="minor">
-            <a:schemeClr val="lt1"/>
-          </a:fontRef>
-        </p:style>
-        <p:txBody>
-          <a:bodyPr wrap="square" rtlCol="0" anchor="ctr"/>
-          <a:lstStyle/>
-          <a:p>
-            <a:pPr algn="ctr"/>
-            <a:r>
-              <a:rPr sz="1000">
-                <a:solidFill>
-                  <a:srgbClr val="262626"/>
-                </a:solidFill>
-              </a:rPr>
-              <a:t>5. Verify</a:t>
-            </a:r>
-          </a:p>
-        </p:txBody>
-      </p:sp>
-      <p:cxnSp>
-        <p:nvCxnSpPr>
-          <p:cNvPr id="28" name="Connector 27"/>
-          <p:cNvCxnSpPr/>
-          <p:nvPr/>
-        </p:nvCxnSpPr>
-        <p:spPr>
-          <a:xfrm>
-            <a:off x="7095744" y="5404104"/>
-            <a:ext cx="219456" cy="0"/>
-          </a:xfrm>
-          <a:prstGeom prst="line">
-            <a:avLst/>
-          </a:prstGeom>
-          <a:ln w="15875">
-            <a:solidFill>
-              <a:srgbClr val="8C8C8C"/>
-            </a:solidFill>
-            <a:tailEnd type="triangle" w="med" len="med"/>
-          </a:ln>
-        </p:spPr>
-        <p:style>
-          <a:lnRef idx="2">
-            <a:schemeClr val="accent1"/>
-          </a:lnRef>
-          <a:fillRef idx="0">
-            <a:schemeClr val="accent1"/>
-          </a:fillRef>
-          <a:effectRef idx="1">
-            <a:schemeClr val="accent1"/>
-          </a:effectRef>
-          <a:fontRef idx="minor">
-            <a:schemeClr val="tx1"/>
-          </a:fontRef>
-        </p:style>
-      </p:cxnSp>
-      <p:sp>
-        <p:nvSpPr>
-          <p:cNvPr id="29" name="Rounded Rectangle 28"/>
-          <p:cNvSpPr/>
-          <p:nvPr/>
-        </p:nvSpPr>
-        <p:spPr>
-          <a:xfrm>
-            <a:off x="7315200" y="5074920"/>
-            <a:ext cx="1133856" cy="658368"/>
-          </a:xfrm>
-          <a:prstGeom prst="roundRect">
-            <a:avLst/>
-          </a:prstGeom>
-          <a:solidFill>
-            <a:srgbClr val="F2F2F2"/>
-          </a:solidFill>
-          <a:ln w="9525">
-            <a:solidFill>
-              <a:srgbClr val="8C8C8C"/>
-            </a:solidFill>
-          </a:ln>
-          <a:effectLst/>
-        </p:spPr>
-        <p:style>
-          <a:lnRef idx="1">
-            <a:schemeClr val="accent1"/>
-          </a:lnRef>
-          <a:fillRef idx="3">
-            <a:schemeClr val="accent1"/>
-          </a:fillRef>
-          <a:effectRef idx="2">
-            <a:schemeClr val="accent1"/>
-          </a:effectRef>
-          <a:fontRef idx="minor">
-            <a:schemeClr val="lt1"/>
-          </a:fontRef>
-        </p:style>
-        <p:txBody>
-          <a:bodyPr wrap="square" rtlCol="0" anchor="ctr"/>
-          <a:lstStyle/>
-          <a:p>
-            <a:pPr algn="ctr"/>
-            <a:r>
-              <a:rPr sz="1000">
-                <a:solidFill>
-                  <a:srgbClr val="262626"/>
-                </a:solidFill>
-              </a:rPr>
-              <a:t>6. Search &amp;
-export</a:t>
-            </a:r>
-          </a:p>
-        </p:txBody>
-      </p:sp>
-      <p:sp>
-        <p:nvSpPr>
-          <p:cNvPr id="30" name="TextBox 29"/>
-          <p:cNvSpPr txBox="1"/>
-          <p:nvPr/>
-        </p:nvSpPr>
-        <p:spPr>
-          <a:xfrm>
-            <a:off x="548640" y="4709160"/>
-            <a:ext cx="5486400" cy="320040"/>
-          </a:xfrm>
-          <a:prstGeom prst="rect">
-            <a:avLst/>
-          </a:prstGeom>
-          <a:noFill/>
-        </p:spPr>
-        <p:txBody>
-          <a:bodyPr wrap="square">
-            <a:spAutoFit/>
-          </a:bodyPr>
-          <a:lstStyle/>
-          <a:p>
-            <a:pPr algn="l"/>
-            <a:r>
-              <a:rPr sz="1200" i="1">
-                <a:solidFill>
-                  <a:srgbClr val="595959"/>
-                </a:solidFill>
-              </a:rPr>
-              <a:t>Methodology: from a voice to verified, searchable text</a:t>
-            </a:r>
-          </a:p>
-        </p:txBody>
-      </p:sp>
     </p:spTree>
   </p:cSld>
   <p:clrMapOvr>
@@ -8148,17 +6901,41 @@
         </p:nvGraphicFramePr>
         <p:xfrm>
           <a:off x="457200" y="2148840"/>
-          <a:ext cx="8229600" cy="4672584"/>
+          <a:ext cx="8229600" cy="3904488"/>
         </p:xfrm>
         <a:graphic>
           <a:graphicData uri="http://schemas.openxmlformats.org/drawingml/2006/table">
             <a:tbl>
               <a:tblPr firstRow="1" bandRow="1"/>
               <a:tblGrid>
-                <a:gridCol w="1371600"/>
-                <a:gridCol w="1828800"/>
-                <a:gridCol w="2468880"/>
-                <a:gridCol w="2560320"/>
+                <a:gridCol w="1371600">
+                  <a:extLst>
+                    <a:ext uri="{9D8B030D-6E8A-4147-A177-3AD203B41FA5}">
+                      <a16:colId xmlns:a16="http://schemas.microsoft.com/office/drawing/2014/main" val="20000"/>
+                    </a:ext>
+                  </a:extLst>
+                </a:gridCol>
+                <a:gridCol w="1828800">
+                  <a:extLst>
+                    <a:ext uri="{9D8B030D-6E8A-4147-A177-3AD203B41FA5}">
+                      <a16:colId xmlns:a16="http://schemas.microsoft.com/office/drawing/2014/main" val="20001"/>
+                    </a:ext>
+                  </a:extLst>
+                </a:gridCol>
+                <a:gridCol w="2468880">
+                  <a:extLst>
+                    <a:ext uri="{9D8B030D-6E8A-4147-A177-3AD203B41FA5}">
+                      <a16:colId xmlns:a16="http://schemas.microsoft.com/office/drawing/2014/main" val="20002"/>
+                    </a:ext>
+                  </a:extLst>
+                </a:gridCol>
+                <a:gridCol w="2560320">
+                  <a:extLst>
+                    <a:ext uri="{9D8B030D-6E8A-4147-A177-3AD203B41FA5}">
+                      <a16:colId xmlns:a16="http://schemas.microsoft.com/office/drawing/2014/main" val="20003"/>
+                    </a:ext>
+                  </a:extLst>
+                </a:gridCol>
               </a:tblGrid>
               <a:tr h="320040">
                 <a:tc>
@@ -8361,6 +7138,11 @@
                     </a:solidFill>
                   </a:tcPr>
                 </a:tc>
+                <a:extLst>
+                  <a:ext uri="{0D108BD9-81ED-4DB2-BD59-A6C34878D82A}">
+                    <a16:rowId xmlns:a16="http://schemas.microsoft.com/office/drawing/2014/main" val="10000"/>
+                  </a:ext>
+                </a:extLst>
               </a:tr>
               <a:tr h="512064">
                 <a:tc>
@@ -8563,6 +7345,11 @@
                     </a:solidFill>
                   </a:tcPr>
                 </a:tc>
+                <a:extLst>
+                  <a:ext uri="{0D108BD9-81ED-4DB2-BD59-A6C34878D82A}">
+                    <a16:rowId xmlns:a16="http://schemas.microsoft.com/office/drawing/2014/main" val="10001"/>
+                  </a:ext>
+                </a:extLst>
               </a:tr>
               <a:tr h="512064">
                 <a:tc>
@@ -8765,6 +7552,11 @@
                     </a:solidFill>
                   </a:tcPr>
                 </a:tc>
+                <a:extLst>
+                  <a:ext uri="{0D108BD9-81ED-4DB2-BD59-A6C34878D82A}">
+                    <a16:rowId xmlns:a16="http://schemas.microsoft.com/office/drawing/2014/main" val="10002"/>
+                  </a:ext>
+                </a:extLst>
               </a:tr>
               <a:tr h="512064">
                 <a:tc>
@@ -8967,6 +7759,11 @@
                     </a:solidFill>
                   </a:tcPr>
                 </a:tc>
+                <a:extLst>
+                  <a:ext uri="{0D108BD9-81ED-4DB2-BD59-A6C34878D82A}">
+                    <a16:rowId xmlns:a16="http://schemas.microsoft.com/office/drawing/2014/main" val="10003"/>
+                  </a:ext>
+                </a:extLst>
               </a:tr>
               <a:tr h="512064">
                 <a:tc>
@@ -9169,6 +7966,11 @@
                     </a:solidFill>
                   </a:tcPr>
                 </a:tc>
+                <a:extLst>
+                  <a:ext uri="{0D108BD9-81ED-4DB2-BD59-A6C34878D82A}">
+                    <a16:rowId xmlns:a16="http://schemas.microsoft.com/office/drawing/2014/main" val="10004"/>
+                  </a:ext>
+                </a:extLst>
               </a:tr>
               <a:tr h="512064">
                 <a:tc>
@@ -9371,6 +8173,11 @@
                     </a:solidFill>
                   </a:tcPr>
                 </a:tc>
+                <a:extLst>
+                  <a:ext uri="{0D108BD9-81ED-4DB2-BD59-A6C34878D82A}">
+                    <a16:rowId xmlns:a16="http://schemas.microsoft.com/office/drawing/2014/main" val="10005"/>
+                  </a:ext>
+                </a:extLst>
               </a:tr>
               <a:tr h="512064">
                 <a:tc>
@@ -9573,6 +8380,11 @@
                     </a:solidFill>
                   </a:tcPr>
                 </a:tc>
+                <a:extLst>
+                  <a:ext uri="{0D108BD9-81ED-4DB2-BD59-A6C34878D82A}">
+                    <a16:rowId xmlns:a16="http://schemas.microsoft.com/office/drawing/2014/main" val="10006"/>
+                  </a:ext>
+                </a:extLst>
               </a:tr>
               <a:tr h="512064">
                 <a:tc>
@@ -9775,6 +8587,11 @@
                     </a:solidFill>
                   </a:tcPr>
                 </a:tc>
+                <a:extLst>
+                  <a:ext uri="{0D108BD9-81ED-4DB2-BD59-A6C34878D82A}">
+                    <a16:rowId xmlns:a16="http://schemas.microsoft.com/office/drawing/2014/main" val="10007"/>
+                  </a:ext>
+                </a:extLst>
               </a:tr>
             </a:tbl>
           </a:graphicData>
@@ -9888,7 +8705,7 @@
                 <a:latin typeface="Times New Roman" panose="02020603050405020304" pitchFamily="18" charset="0"/>
                 <a:cs typeface="Times New Roman" panose="02020603050405020304" pitchFamily="18" charset="0"/>
               </a:rPr>
-              <a:t>Results</a:t>
+              <a:t>Implementation Details (Algorithm)</a:t>
             </a:r>
             <a:endParaRPr sz="2400" dirty="0">
               <a:latin typeface="Times New Roman" panose="02020603050405020304" pitchFamily="18" charset="0"/>
@@ -9897,45 +8714,188 @@
           </a:p>
         </p:txBody>
       </p:sp>
-      <p:pic>
-        <p:nvPicPr>
-          <p:cNvPr id="4" name="Picture 3" descr="cover.png"/>
-          <p:cNvPicPr>
-            <a:picLocks noChangeAspect="1"/>
-          </p:cNvPicPr>
-          <p:nvPr/>
-        </p:nvPicPr>
-        <p:blipFill>
-          <a:blip r:embed="rId2"/>
-          <a:stretch>
-            <a:fillRect/>
-          </a:stretch>
-        </p:blipFill>
-        <p:spPr>
-          <a:xfrm>
-            <a:off x="502920" y="2011680"/>
-            <a:ext cx="2606040" cy="1628775"/>
-          </a:xfrm>
-          <a:prstGeom prst="rect">
-            <a:avLst/>
-          </a:prstGeom>
-          <a:ln w="9525">
-            <a:solidFill>
-              <a:srgbClr val="8C8C8C"/>
-            </a:solidFill>
-          </a:ln>
-        </p:spPr>
-      </p:pic>
       <p:sp>
         <p:nvSpPr>
-          <p:cNvPr id="5" name="TextBox 4"/>
+          <p:cNvPr id="5" name="Google Shape;69;g78e6671419f8a2a0_22">
+            <a:extLst>
+              <a:ext uri="{FF2B5EF4-FFF2-40B4-BE49-F238E27FC236}">
+                <a16:creationId xmlns:a16="http://schemas.microsoft.com/office/drawing/2014/main" id="{13186C97-59A2-67F5-3892-203B43C861C9}"/>
+              </a:ext>
+            </a:extLst>
+          </p:cNvPr>
           <p:cNvSpPr txBox="1"/>
           <p:nvPr/>
         </p:nvSpPr>
         <p:spPr>
           <a:xfrm>
-            <a:off x="502920" y="3630168"/>
-            <a:ext cx="2606040" cy="274320"/>
+            <a:off x="822960" y="2286000"/>
+            <a:ext cx="7589520" cy="2834640"/>
+          </a:xfrm>
+          <a:prstGeom prst="rect">
+            <a:avLst/>
+          </a:prstGeom>
+          <a:noFill/>
+          <a:ln>
+            <a:noFill/>
+          </a:ln>
+        </p:spPr>
+        <p:txBody>
+          <a:bodyPr spcFirstLastPara="1" wrap="square" lIns="68569" tIns="34275" rIns="68569" bIns="34275" anchor="t" anchorCtr="0">
+            <a:noAutofit/>
+          </a:bodyPr>
+          <a:lstStyle/>
+          <a:p>
+            <a:pPr marL="457200" indent="-342900">
+              <a:lnSpc>
+                <a:spcPct val="90000"/>
+              </a:lnSpc>
+              <a:spcBef>
+                <a:spcPts val="700"/>
+              </a:spcBef>
+              <a:buFont typeface="+mj-lt"/>
+              <a:buAutoNum type="arabicPeriod"/>
+            </a:pPr>
+            <a:r>
+              <a:rPr lang="en-US" sz="1400" dirty="0">
+                <a:solidFill>
+                  <a:srgbClr val="595959"/>
+                </a:solidFill>
+              </a:rPr>
+              <a:t>If a job for R is queued or running, return it; otherwise create job J</a:t>
+            </a:r>
+          </a:p>
+          <a:p>
+            <a:pPr marL="457200" indent="-342900">
+              <a:lnSpc>
+                <a:spcPct val="90000"/>
+              </a:lnSpc>
+              <a:spcBef>
+                <a:spcPts val="700"/>
+              </a:spcBef>
+              <a:buFont typeface="+mj-lt"/>
+              <a:buAutoNum type="arabicPeriod"/>
+            </a:pPr>
+            <a:r>
+              <a:rPr lang="en-US" sz="1400" dirty="0">
+                <a:solidFill>
+                  <a:srgbClr val="595959"/>
+                </a:solidFill>
+              </a:rPr>
+              <a:t>Download R’s audio (up to 200 MB)</a:t>
+            </a:r>
+          </a:p>
+          <a:p>
+            <a:pPr marL="457200" indent="-342900">
+              <a:lnSpc>
+                <a:spcPct val="90000"/>
+              </a:lnSpc>
+              <a:spcBef>
+                <a:spcPts val="700"/>
+              </a:spcBef>
+              <a:buFont typeface="+mj-lt"/>
+              <a:buAutoNum type="arabicPeriod"/>
+            </a:pPr>
+            <a:r>
+              <a:rPr lang="en-US" sz="1400" dirty="0">
+                <a:solidFill>
+                  <a:srgbClr val="595959"/>
+                </a:solidFill>
+              </a:rPr>
+              <a:t>a ← ffmpeg(audio): mono, 16 kHz, high-pass 80 Hz, loudness −18 LUFS, Opus 32 kbps</a:t>
+            </a:r>
+          </a:p>
+          <a:p>
+            <a:pPr marL="457200" indent="-342900">
+              <a:lnSpc>
+                <a:spcPct val="90000"/>
+              </a:lnSpc>
+              <a:spcBef>
+                <a:spcPts val="700"/>
+              </a:spcBef>
+              <a:buFont typeface="+mj-lt"/>
+              <a:buAutoNum type="arabicPeriod"/>
+            </a:pPr>
+            <a:r>
+              <a:rPr lang="en-US" sz="1400" dirty="0">
+                <a:solidFill>
+                  <a:srgbClr val="595959"/>
+                </a:solidFill>
+              </a:rPr>
+              <a:t>S ← Whisper-large-v3(a, language = D.asr_language) → timestamped segments</a:t>
+            </a:r>
+          </a:p>
+          <a:p>
+            <a:pPr marL="457200" indent="-342900">
+              <a:lnSpc>
+                <a:spcPct val="90000"/>
+              </a:lnSpc>
+              <a:spcBef>
+                <a:spcPts val="700"/>
+              </a:spcBef>
+              <a:buFont typeface="+mj-lt"/>
+              <a:buAutoNum type="arabicPeriod"/>
+            </a:pPr>
+            <a:r>
+              <a:rPr lang="en-US" sz="1400" dirty="0">
+                <a:solidFill>
+                  <a:srgbClr val="595959"/>
+                </a:solidFill>
+              </a:rPr>
+              <a:t>Replace R’s segments with S;  R.status ← transcribed</a:t>
+            </a:r>
+          </a:p>
+          <a:p>
+            <a:pPr marL="457200" indent="-342900">
+              <a:lnSpc>
+                <a:spcPct val="90000"/>
+              </a:lnSpc>
+              <a:spcBef>
+                <a:spcPts val="700"/>
+              </a:spcBef>
+              <a:buFont typeface="+mj-lt"/>
+              <a:buAutoNum type="arabicPeriod"/>
+            </a:pPr>
+            <a:r>
+              <a:rPr lang="en-US" sz="1400" dirty="0">
+                <a:solidFill>
+                  <a:srgbClr val="595959"/>
+                </a:solidFill>
+              </a:rPr>
+              <a:t>For each segment s:  s.embedding ← MiniLM(s.text)  (384-dimensional)</a:t>
+            </a:r>
+          </a:p>
+          <a:p>
+            <a:pPr marL="457200" indent="-342900">
+              <a:lnSpc>
+                <a:spcPct val="90000"/>
+              </a:lnSpc>
+              <a:spcBef>
+                <a:spcPts val="700"/>
+              </a:spcBef>
+              <a:buFont typeface="+mj-lt"/>
+              <a:buAutoNum type="arabicPeriod"/>
+            </a:pPr>
+            <a:r>
+              <a:rPr lang="en-US" sz="1400" dirty="0">
+                <a:solidFill>
+                  <a:srgbClr val="595959"/>
+                </a:solidFill>
+              </a:rPr>
+              <a:t>J.status ← completed (progress 5 → 25 → 70 → 85 → 100 %); on error J.status ← failed</a:t>
+            </a:r>
+          </a:p>
+        </p:txBody>
+      </p:sp>
+      <p:sp>
+        <p:nvSpPr>
+          <p:cNvPr id="6" name="TextBox 5"/>
+          <p:cNvSpPr txBox="1"/>
+          <p:nvPr/>
+        </p:nvSpPr>
+        <p:spPr>
+          <a:xfrm>
+            <a:off x="822960" y="1920240"/>
+            <a:ext cx="7589520" cy="365760"/>
           </a:xfrm>
           <a:prstGeom prst="rect">
             <a:avLst/>
@@ -9948,47 +8908,18 @@
           </a:bodyPr>
           <a:lstStyle/>
           <a:p>
-            <a:pPr algn="ctr"/>
+            <a:pPr algn="l"/>
             <a:r>
-              <a:rPr sz="1000" i="1">
+              <a:rPr sz="1400" b="1" i="0">
                 <a:solidFill>
                   <a:srgbClr val="595959"/>
                 </a:solidFill>
               </a:rPr>
-              <a:t>Sign-in page: logo in 10 scripts</a:t>
+              <a:t>Transcription with Vani — input: recording R with audio file, dialect D</a:t>
             </a:r>
           </a:p>
         </p:txBody>
       </p:sp>
-      <p:pic>
-        <p:nvPicPr>
-          <p:cNvPr id="6" name="Picture 5" descr="recording.png"/>
-          <p:cNvPicPr>
-            <a:picLocks noChangeAspect="1"/>
-          </p:cNvPicPr>
-          <p:nvPr/>
-        </p:nvPicPr>
-        <p:blipFill>
-          <a:blip r:embed="rId3"/>
-          <a:stretch>
-            <a:fillRect/>
-          </a:stretch>
-        </p:blipFill>
-        <p:spPr>
-          <a:xfrm>
-            <a:off x="3291839" y="2011680"/>
-            <a:ext cx="2606040" cy="1628775"/>
-          </a:xfrm>
-          <a:prstGeom prst="rect">
-            <a:avLst/>
-          </a:prstGeom>
-          <a:ln w="9525">
-            <a:solidFill>
-              <a:srgbClr val="8C8C8C"/>
-            </a:solidFill>
-          </a:ln>
-        </p:spPr>
-      </p:pic>
       <p:sp>
         <p:nvSpPr>
           <p:cNvPr id="7" name="TextBox 6"/>
@@ -9997,8 +8928,8 @@
         </p:nvSpPr>
         <p:spPr>
           <a:xfrm>
-            <a:off x="3291839" y="3630168"/>
-            <a:ext cx="2606040" cy="274320"/>
+            <a:off x="822960" y="4846320"/>
+            <a:ext cx="7589520" cy="731520"/>
           </a:xfrm>
           <a:prstGeom prst="rect">
             <a:avLst/>
@@ -10011,245 +8942,22 @@
           </a:bodyPr>
           <a:lstStyle/>
           <a:p>
-            <a:pPr algn="ctr"/>
+            <a:pPr algn="l"/>
             <a:r>
-              <a:rPr sz="1000" i="1">
+              <a:rPr sz="1200" b="1">
                 <a:solidFill>
                   <a:srgbClr val="595959"/>
                 </a:solidFill>
               </a:rPr>
-              <a:t>Recording page: Vani’s transcript</a:t>
-            </a:r>
-          </a:p>
-        </p:txBody>
-      </p:sp>
-      <p:pic>
-        <p:nvPicPr>
-          <p:cNvPr id="8" name="Picture 7" descr="shelf.png"/>
-          <p:cNvPicPr>
-            <a:picLocks noChangeAspect="1"/>
-          </p:cNvPicPr>
-          <p:nvPr/>
-        </p:nvPicPr>
-        <p:blipFill>
-          <a:blip r:embed="rId4"/>
-          <a:stretch>
-            <a:fillRect/>
-          </a:stretch>
-        </p:blipFill>
-        <p:spPr>
-          <a:xfrm>
-            <a:off x="6080759" y="2011680"/>
-            <a:ext cx="2606040" cy="1628775"/>
-          </a:xfrm>
-          <a:prstGeom prst="rect">
-            <a:avLst/>
-          </a:prstGeom>
-          <a:ln w="9525">
-            <a:solidFill>
-              <a:srgbClr val="8C8C8C"/>
-            </a:solidFill>
-          </a:ln>
-        </p:spPr>
-      </p:pic>
-      <p:sp>
-        <p:nvSpPr>
-          <p:cNvPr id="9" name="TextBox 8"/>
-          <p:cNvSpPr txBox="1"/>
-          <p:nvPr/>
-        </p:nvSpPr>
-        <p:spPr>
-          <a:xfrm>
-            <a:off x="6080759" y="3630168"/>
-            <a:ext cx="2606040" cy="274320"/>
-          </a:xfrm>
-          <a:prstGeom prst="rect">
-            <a:avLst/>
-          </a:prstGeom>
-          <a:noFill/>
-        </p:spPr>
-        <p:txBody>
-          <a:bodyPr wrap="square">
-            <a:spAutoFit/>
-          </a:bodyPr>
-          <a:lstStyle/>
-          <a:p>
-            <a:pPr algn="ctr"/>
-            <a:r>
-              <a:rPr sz="1000" i="1">
-                <a:solidFill>
-                  <a:srgbClr val="595959"/>
-                </a:solidFill>
-              </a:rPr>
-              <a:t>Dialect shelf: 74 dialects</a:t>
-            </a:r>
-          </a:p>
-        </p:txBody>
-      </p:sp>
-      <p:sp>
-        <p:nvSpPr>
-          <p:cNvPr id="10" name="TextBox 9"/>
-          <p:cNvSpPr txBox="1"/>
-          <p:nvPr/>
-        </p:nvSpPr>
-        <p:spPr>
-          <a:xfrm>
-            <a:off x="822960" y="4069080"/>
-            <a:ext cx="7589520" cy="2194560"/>
-          </a:xfrm>
-          <a:prstGeom prst="rect">
-            <a:avLst/>
-          </a:prstGeom>
-          <a:noFill/>
-        </p:spPr>
-        <p:txBody>
-          <a:bodyPr wrap="square">
-            <a:spAutoFit/>
-          </a:bodyPr>
-          <a:lstStyle/>
-          <a:p>
-            <a:pPr marL="457200" indent="-342900">
-              <a:lnSpc>
-                <a:spcPct val="90000"/>
-              </a:lnSpc>
-              <a:spcBef>
-                <a:spcPts val="500"/>
-              </a:spcBef>
-              <a:buSzPts val="1800"/>
-              <a:buFont typeface="Arial"/>
-              <a:buChar char="•"/>
-            </a:pPr>
-            <a:r>
-              <a:rPr lang="en-US" sz="1400" b="1" dirty="0">
-                <a:solidFill>
-                  <a:srgbClr val="595959"/>
-                </a:solidFill>
-              </a:rPr>
-              <a:t>Deployed live: </a:t>
+              <a:t>Also: </a:t>
             </a:r>
             <a:r>
-              <a:rPr lang="en-US" sz="1400" dirty="0">
+              <a:rPr sz="1200" i="0">
                 <a:solidFill>
                   <a:srgbClr val="595959"/>
                 </a:solidFill>
               </a:rPr>
-              <a:t>swara-veda.vercel.app with a FastAPI server on Render and a Supabase database</a:t>
-            </a:r>
-          </a:p>
-          <a:p>
-            <a:pPr marL="457200" indent="-342900">
-              <a:lnSpc>
-                <a:spcPct val="90000"/>
-              </a:lnSpc>
-              <a:spcBef>
-                <a:spcPts val="500"/>
-              </a:spcBef>
-              <a:buSzPts val="1800"/>
-              <a:buFont typeface="Arial"/>
-              <a:buChar char="•"/>
-            </a:pPr>
-            <a:r>
-              <a:rPr lang="en-US" sz="1400" b="1" dirty="0">
-                <a:solidFill>
-                  <a:srgbClr val="595959"/>
-                </a:solidFill>
-              </a:rPr>
-              <a:t>74 dialects </a:t>
-            </a:r>
-            <a:r>
-              <a:rPr lang="en-US" sz="1400" dirty="0">
-                <a:solidFill>
-                  <a:srgbClr val="595959"/>
-                </a:solidFill>
-              </a:rPr>
-              <a:t>catalogued with region, script, ISO code and Vani’s language hint</a:t>
-            </a:r>
-          </a:p>
-          <a:p>
-            <a:pPr marL="457200" indent="-342900">
-              <a:lnSpc>
-                <a:spcPct val="90000"/>
-              </a:lnSpc>
-              <a:spcBef>
-                <a:spcPts val="500"/>
-              </a:spcBef>
-              <a:buSzPts val="1800"/>
-              <a:buFont typeface="Arial"/>
-              <a:buChar char="•"/>
-            </a:pPr>
-            <a:r>
-              <a:rPr lang="en-US" sz="1400" b="1" dirty="0">
-                <a:solidFill>
-                  <a:srgbClr val="595959"/>
-                </a:solidFill>
-              </a:rPr>
-              <a:t>100+ automated tests </a:t>
-            </a:r>
-            <a:r>
-              <a:rPr lang="en-US" sz="1400" dirty="0">
-                <a:solidFill>
-                  <a:srgbClr val="595959"/>
-                </a:solidFill>
-              </a:rPr>
-              <a:t>pass, plus tests on real PostgreSQL; end-to-end browser tests show no errors</a:t>
-            </a:r>
-          </a:p>
-          <a:p>
-            <a:pPr marL="457200" indent="-342900">
-              <a:lnSpc>
-                <a:spcPct val="90000"/>
-              </a:lnSpc>
-              <a:spcBef>
-                <a:spcPts val="500"/>
-              </a:spcBef>
-              <a:buSzPts val="1800"/>
-              <a:buFont typeface="Arial"/>
-              <a:buChar char="•"/>
-            </a:pPr>
-            <a:r>
-              <a:rPr lang="en-US" sz="1400" b="1" dirty="0">
-                <a:solidFill>
-                  <a:srgbClr val="595959"/>
-                </a:solidFill>
-              </a:rPr>
-              <a:t>Pre-processing: </a:t>
-            </a:r>
-            <a:r>
-              <a:rPr lang="en-US" sz="1400" dirty="0">
-                <a:solidFill>
-                  <a:srgbClr val="595959"/>
-                </a:solidFill>
-              </a:rPr>
-              <a:t>a 2 MB stereo WAV becomes 24 KB before it is sent to Whisper</a:t>
-            </a:r>
-          </a:p>
-          <a:p>
-            <a:pPr marL="457200" indent="-342900">
-              <a:lnSpc>
-                <a:spcPct val="90000"/>
-              </a:lnSpc>
-              <a:spcBef>
-                <a:spcPts val="500"/>
-              </a:spcBef>
-              <a:buSzPts val="1800"/>
-              <a:buFont typeface="Arial"/>
-              <a:buChar char="•"/>
-            </a:pPr>
-            <a:r>
-              <a:rPr lang="en-US" sz="1400" b="1" dirty="0">
-                <a:solidFill>
-                  <a:srgbClr val="595959"/>
-                </a:solidFill>
-              </a:rPr>
-              <a:t>Works offline: </a:t>
-            </a:r>
-            <a:r>
-              <a:rPr lang="en-US" sz="1400" dirty="0">
-                <a:solidFill>
-                  <a:srgbClr val="595959"/>
-                </a:solidFill>
-              </a:rPr>
-              <a:t>recordings are saved on the device and upload by themselves later</a:t>
+              <a:t>keyword search with PostgreSQL full-text ranking; search by meaning with pgvector cosine distance; corrections are re-embedded; offline recordings wait in IndexedDB and upload when the connection returns.</a:t>
             </a:r>
           </a:p>
         </p:txBody>
@@ -10279,36 +8987,308 @@
           <a:chExt cx="0" cy="0"/>
         </a:xfrm>
       </p:grpSpPr>
-      <p:pic>
-        <p:nvPicPr>
-          <p:cNvPr id="4" name="Picture 3">
+      <p:sp>
+        <p:nvSpPr>
+          <p:cNvPr id="3" name="Google Shape;68;g78e6671419f8a2a0_22">
             <a:extLst>
               <a:ext uri="{FF2B5EF4-FFF2-40B4-BE49-F238E27FC236}">
-                <a16:creationId xmlns:a16="http://schemas.microsoft.com/office/drawing/2014/main" id="{2CBC3EA0-6A61-A69C-F4DE-DAFDF30506BA}"/>
+                <a16:creationId xmlns:a16="http://schemas.microsoft.com/office/drawing/2014/main" id="{BA677A83-D006-E1F4-CCF8-948027C21AB2}"/>
               </a:ext>
             </a:extLst>
           </p:cNvPr>
+          <p:cNvSpPr txBox="1"/>
+          <p:nvPr/>
+        </p:nvSpPr>
+        <p:spPr>
+          <a:xfrm>
+            <a:off x="628650" y="1131097"/>
+            <a:ext cx="7886700" cy="994275"/>
+          </a:xfrm>
+          <a:prstGeom prst="rect">
+            <a:avLst/>
+          </a:prstGeom>
+          <a:noFill/>
+          <a:ln>
+            <a:noFill/>
+          </a:ln>
+        </p:spPr>
+        <p:txBody>
+          <a:bodyPr spcFirstLastPara="1" wrap="square" lIns="68569" tIns="34275" rIns="68569" bIns="34275" anchor="ctr" anchorCtr="0">
+            <a:normAutofit/>
+          </a:bodyPr>
+          <a:lstStyle/>
+          <a:p>
+            <a:pPr algn="ctr" defTabSz="685800">
+              <a:lnSpc>
+                <a:spcPct val="90000"/>
+              </a:lnSpc>
+            </a:pPr>
+            <a:r>
+              <a:rPr lang="en-GB" sz="2400" dirty="0">
+                <a:latin typeface="Times New Roman" panose="02020603050405020304" pitchFamily="18" charset="0"/>
+                <a:cs typeface="Times New Roman" panose="02020603050405020304" pitchFamily="18" charset="0"/>
+              </a:rPr>
+              <a:t>Results</a:t>
+            </a:r>
+            <a:endParaRPr sz="2400" dirty="0">
+              <a:latin typeface="Times New Roman" panose="02020603050405020304" pitchFamily="18" charset="0"/>
+              <a:cs typeface="Times New Roman" panose="02020603050405020304" pitchFamily="18" charset="0"/>
+            </a:endParaRPr>
+          </a:p>
+        </p:txBody>
+      </p:sp>
+      <p:pic>
+        <p:nvPicPr>
+          <p:cNvPr id="40" name="Result screenshot 1" descr="Sign-in: logo in 10 scripts, Google sign-in"/>
           <p:cNvPicPr>
             <a:picLocks noChangeAspect="1"/>
           </p:cNvPicPr>
           <p:nvPr/>
         </p:nvPicPr>
         <p:blipFill>
-          <a:blip r:embed="rId2"/>
+          <a:blip r:embed="rId20"/>
           <a:stretch>
             <a:fillRect/>
           </a:stretch>
         </p:blipFill>
         <p:spPr>
           <a:xfrm>
-            <a:off x="0" y="1316736"/>
-            <a:ext cx="9143999" cy="5541264"/>
+            <a:off x="1165860" y="1965960"/>
+            <a:ext cx="3291840" cy="1874520"/>
           </a:xfrm>
           <a:prstGeom prst="rect">
             <a:avLst/>
           </a:prstGeom>
+          <a:ln w="9525">
+            <a:solidFill>
+              <a:srgbClr val="BFBFBF"/>
+            </a:solidFill>
+          </a:ln>
         </p:spPr>
       </p:pic>
+      <p:sp>
+        <p:nvSpPr>
+          <p:cNvPr id="41" name="Result caption 1"/>
+          <p:cNvSpPr txBox="1"/>
+          <p:nvPr/>
+        </p:nvSpPr>
+        <p:spPr>
+          <a:xfrm>
+            <a:off x="1165860" y="3840480"/>
+            <a:ext cx="3291840" cy="274320"/>
+          </a:xfrm>
+          <a:prstGeom prst="rect">
+            <a:avLst/>
+          </a:prstGeom>
+          <a:noFill/>
+        </p:spPr>
+        <p:txBody>
+          <a:bodyPr wrap="square">
+            <a:spAutoFit/>
+          </a:bodyPr>
+          <a:lstStyle/>
+          <a:p>
+            <a:pPr algn="ctr"/>
+            <a:r>
+              <a:rPr sz="1000" i="1">
+                <a:solidFill>
+                  <a:srgbClr val="595959"/>
+                </a:solidFill>
+              </a:rPr>
+              <a:t>Sign-in: logo in 10 scripts, Google sign-in</a:t>
+            </a:r>
+          </a:p>
+        </p:txBody>
+      </p:sp>
+      <p:pic>
+        <p:nvPicPr>
+          <p:cNvPr id="42" name="Result screenshot 2" descr="Home: live archive numbers"/>
+          <p:cNvPicPr>
+            <a:picLocks noChangeAspect="1"/>
+          </p:cNvPicPr>
+          <p:nvPr/>
+        </p:nvPicPr>
+        <p:blipFill>
+          <a:blip r:embed="rId21"/>
+          <a:stretch>
+            <a:fillRect/>
+          </a:stretch>
+        </p:blipFill>
+        <p:spPr>
+          <a:xfrm>
+            <a:off x="4686300" y="1965960"/>
+            <a:ext cx="3291840" cy="1874520"/>
+          </a:xfrm>
+          <a:prstGeom prst="rect">
+            <a:avLst/>
+          </a:prstGeom>
+          <a:ln w="9525">
+            <a:solidFill>
+              <a:srgbClr val="BFBFBF"/>
+            </a:solidFill>
+          </a:ln>
+        </p:spPr>
+      </p:pic>
+      <p:sp>
+        <p:nvSpPr>
+          <p:cNvPr id="43" name="Result caption 2"/>
+          <p:cNvSpPr txBox="1"/>
+          <p:nvPr/>
+        </p:nvSpPr>
+        <p:spPr>
+          <a:xfrm>
+            <a:off x="4686300" y="3840480"/>
+            <a:ext cx="3291840" cy="274320"/>
+          </a:xfrm>
+          <a:prstGeom prst="rect">
+            <a:avLst/>
+          </a:prstGeom>
+          <a:noFill/>
+        </p:spPr>
+        <p:txBody>
+          <a:bodyPr wrap="square">
+            <a:spAutoFit/>
+          </a:bodyPr>
+          <a:lstStyle/>
+          <a:p>
+            <a:pPr algn="ctr"/>
+            <a:r>
+              <a:rPr sz="1000" i="1">
+                <a:solidFill>
+                  <a:srgbClr val="595959"/>
+                </a:solidFill>
+              </a:rPr>
+              <a:t>Home: live archive numbers</a:t>
+            </a:r>
+          </a:p>
+        </p:txBody>
+      </p:sp>
+      <p:pic>
+        <p:nvPicPr>
+          <p:cNvPr id="44" name="Result screenshot 3" descr="Archive: recordings with review status"/>
+          <p:cNvPicPr>
+            <a:picLocks noChangeAspect="1"/>
+          </p:cNvPicPr>
+          <p:nvPr/>
+        </p:nvPicPr>
+        <p:blipFill>
+          <a:blip r:embed="rId22"/>
+          <a:stretch>
+            <a:fillRect/>
+          </a:stretch>
+        </p:blipFill>
+        <p:spPr>
+          <a:xfrm>
+            <a:off x="1165860" y="4206240"/>
+            <a:ext cx="3291840" cy="1874520"/>
+          </a:xfrm>
+          <a:prstGeom prst="rect">
+            <a:avLst/>
+          </a:prstGeom>
+          <a:ln w="9525">
+            <a:solidFill>
+              <a:srgbClr val="BFBFBF"/>
+            </a:solidFill>
+          </a:ln>
+        </p:spPr>
+      </p:pic>
+      <p:sp>
+        <p:nvSpPr>
+          <p:cNvPr id="45" name="Result caption 3"/>
+          <p:cNvSpPr txBox="1"/>
+          <p:nvPr/>
+        </p:nvSpPr>
+        <p:spPr>
+          <a:xfrm>
+            <a:off x="1165860" y="6080760"/>
+            <a:ext cx="3291840" cy="274320"/>
+          </a:xfrm>
+          <a:prstGeom prst="rect">
+            <a:avLst/>
+          </a:prstGeom>
+          <a:noFill/>
+        </p:spPr>
+        <p:txBody>
+          <a:bodyPr wrap="square">
+            <a:spAutoFit/>
+          </a:bodyPr>
+          <a:lstStyle/>
+          <a:p>
+            <a:pPr algn="ctr"/>
+            <a:r>
+              <a:rPr sz="1000" i="1">
+                <a:solidFill>
+                  <a:srgbClr val="595959"/>
+                </a:solidFill>
+              </a:rPr>
+              <a:t>Archive: recordings with review status</a:t>
+            </a:r>
+          </a:p>
+        </p:txBody>
+      </p:sp>
+      <p:pic>
+        <p:nvPicPr>
+          <p:cNvPr id="46" name="Result screenshot 4" descr="Dialect shelf: 140 dialects, 6 regions, search"/>
+          <p:cNvPicPr>
+            <a:picLocks noChangeAspect="1"/>
+          </p:cNvPicPr>
+          <p:nvPr/>
+        </p:nvPicPr>
+        <p:blipFill>
+          <a:blip r:embed="rId23"/>
+          <a:stretch>
+            <a:fillRect/>
+          </a:stretch>
+        </p:blipFill>
+        <p:spPr>
+          <a:xfrm>
+            <a:off x="4686300" y="4206240"/>
+            <a:ext cx="3291840" cy="1874520"/>
+          </a:xfrm>
+          <a:prstGeom prst="rect">
+            <a:avLst/>
+          </a:prstGeom>
+          <a:ln w="9525">
+            <a:solidFill>
+              <a:srgbClr val="BFBFBF"/>
+            </a:solidFill>
+          </a:ln>
+        </p:spPr>
+      </p:pic>
+      <p:sp>
+        <p:nvSpPr>
+          <p:cNvPr id="47" name="Result caption 4"/>
+          <p:cNvSpPr txBox="1"/>
+          <p:nvPr/>
+        </p:nvSpPr>
+        <p:spPr>
+          <a:xfrm>
+            <a:off x="4686300" y="6080760"/>
+            <a:ext cx="3291840" cy="274320"/>
+          </a:xfrm>
+          <a:prstGeom prst="rect">
+            <a:avLst/>
+          </a:prstGeom>
+          <a:noFill/>
+        </p:spPr>
+        <p:txBody>
+          <a:bodyPr wrap="square">
+            <a:spAutoFit/>
+          </a:bodyPr>
+          <a:lstStyle/>
+          <a:p>
+            <a:pPr algn="ctr"/>
+            <a:r>
+              <a:rPr sz="1000" i="1">
+                <a:solidFill>
+                  <a:srgbClr val="595959"/>
+                </a:solidFill>
+              </a:rPr>
+              <a:t>Dialect shelf: 140 dialects, 6 regions, search</a:t>
+            </a:r>
+          </a:p>
+        </p:txBody>
+      </p:sp>
     </p:spTree>
   </p:cSld>
   <p:clrMapOvr>

</xml_diff>